<commit_message>
Sprint 5 slides follow the video template, Darron placeholders
</commit_message>
<xml_diff>
--- a/Sprints/Sprint_5/Sprint 5 Presentation.pptx
+++ b/Sprints/Sprint_5/Sprint 5 Presentation.pptx
@@ -1243,7 +1243,7 @@
           </a:p>
           <a:p>
             <a:r>
-              <a:t>Integration and system tests run the real SDK against the fake Signal Hub, which speaks the real wire protocol. Client feedback: fill in Joe's comments from the October MoMs before recording. If there is no client feedback for a point, say so.</a:t>
+              <a:t>Integration and system tests run the real SDK against the fake Signal Hub, which speaks the real wire protocol. Client feedback: September 28, Joe said crashing an engineer's Python session is not acceptable, and the bridge recovery answers that. October feedback is in the MoMs.</a:t>
             </a:r>
           </a:p>
         </p:txBody>
@@ -1318,7 +1318,7 @@
           </a:p>
           <a:p>
             <a:r>
-              <a:t>Show the board. Done has #44 and #45, In review has #46 to #50 and PR #51, Ready has #36. Each member names the issues they worked on. Add your own issues to the board before recording.</a:t>
+              <a:t>Show the board. Done has #44 and #45, In review has #46, #48 to #50 and PR #51, In progress has #52, Ready has #36, #53, #54 and #55. Each member names their issues.</a:t>
             </a:r>
           </a:p>
         </p:txBody>
@@ -1393,7 +1393,7 @@
           </a:p>
           <a:p>
             <a:r>
-              <a:t>Open Sprints/Sprint_5/MoM on GitHub. The files follow the Sprint 4 format. Fill in the dates, attendees, decisions and Joe's feedback from the meeting transcripts before recording, then walk through both meetings here.</a:t>
+              <a:t>Open Sprints/Sprint_5/MoM on GitHub. The files follow the Sprint 4 format. October 12 was the Go and C# comparison. October 26 was the Sprint 5 review.</a:t>
             </a:r>
           </a:p>
         </p:txBody>
@@ -1468,7 +1468,7 @@
           </a:p>
           <a:p>
             <a:r>
-              <a:t>Scroll through Sprints/Sprint_5/Sprint_Report.md on the PR branch. Point out the deliverable status table, testing table, GenAI section and retrospective. Then the docs/Sprint5 folder and the README changes.</a:t>
+              <a:t>Scroll through Sprints/Sprint_5/Sprint_Report.md on the PR branch. Point out the deliverable status table, issue lists and retrospective. Then the new section V in the final report, the docs/Sprint5 folder and the README.</a:t>
             </a:r>
           </a:p>
         </p:txBody>
@@ -1993,7 +1993,7 @@
           </a:p>
           <a:p>
             <a:r>
-              <a:t>Name each feature and its issue. Caleb, Genevieve and Darron: add a row for each feature you built and demo it right after this slide. Only list work that has an issue on the board.</a:t>
+              <a:t>Each member names their features and issues. Caleb shows the team CI run (#52), Genevieve the C# evaluation status and the user guide (#36, #53), Darron &lt;placeholder&gt;. Lucas demos the bridge, the pub/sub example, and the Python.NET spike on the next slides.</a:t>
             </a:r>
           </a:p>
         </p:txBody>
@@ -2368,7 +2368,7 @@
           </a:p>
           <a:p>
             <a:r>
-              <a:t>The old ci.yml printed messages and passed even when a build failed, so it is not used as evidence. tests.yml runs on every push and pull request and fails when a test fails. Show run 41144016907: 11 of 11 jobs passed. Then the compatibility matrix in docs/Sprint5.</a:t>
+              <a:t>Show the team CI pipeline run on the Sprint 5 branch (run 41146542375), 13 of 13 jobs passed. It runs on every push and pull request. Then the compatibility matrix in docs/Sprint5.</a:t>
             </a:r>
           </a:p>
         </p:txBody>
@@ -23706,7 +23706,7 @@
           <a:lstStyle/>
           <a:p>
             <a:r>
-              <a:t>System testing and client feedback</a:t>
+              <a:t>User Testing and Feedback from the Client</a:t>
             </a:r>
           </a:p>
         </p:txBody>
@@ -23913,7 +23913,7 @@
             <a:avLst/>
           </a:prstGeom>
           <a:solidFill>
-            <a:srgbClr val="FDE4DE"/>
+            <a:srgbClr val="E9EDF2"/>
           </a:solidFill>
           <a:ln>
             <a:noFill/>
@@ -23944,7 +23944,7 @@
               </a:spcAft>
             </a:pPr>
             <a:r>
-              <a:rPr sz="1600" b="1">
+              <a:rPr sz="1800" b="1">
                 <a:solidFill>
                   <a:srgbClr val="003A5D"/>
                 </a:solidFill>
@@ -23959,12 +23959,12 @@
               </a:spcAft>
             </a:pPr>
             <a:r>
-              <a:rPr sz="1400">
+              <a:rPr sz="1600">
                 <a:solidFill>
                   <a:srgbClr val="003A5D"/>
                 </a:solidFill>
               </a:rPr>
-              <a:t>Add Joe's feedback from the Sprint 5 meetings here.</a:t>
+              <a:t>Sept 28: crashing a Python session is not acceptable. Sprint 5 bridge recovery answers it.</a:t>
             </a:r>
           </a:p>
           <a:p>
@@ -23974,12 +23974,27 @@
               </a:spcAft>
             </a:pPr>
             <a:r>
-              <a:rPr sz="1400">
+              <a:rPr sz="1600">
                 <a:solidFill>
                   <a:srgbClr val="003A5D"/>
                 </a:solidFill>
               </a:rPr>
-              <a:t>Not tested by SEL users or on a real Signal Hub yet.</a:t>
+              <a:t>&lt;placeholder&gt; October feedback from the MoMs &lt;/placeholder&gt;</a:t>
+            </a:r>
+          </a:p>
+          <a:p>
+            <a:pPr>
+              <a:spcAft>
+                <a:spcPts val="500"/>
+              </a:spcAft>
+            </a:pPr>
+            <a:r>
+              <a:rPr sz="1600">
+                <a:solidFill>
+                  <a:srgbClr val="003A5D"/>
+                </a:solidFill>
+              </a:rPr>
+              <a:t>Not tested on a real Signal Hub yet.</a:t>
             </a:r>
           </a:p>
         </p:txBody>
@@ -24018,7 +24033,7 @@
           <a:lstStyle/>
           <a:p>
             <a:r>
-              <a:t>Kanban board and team contributions</a:t>
+              <a:t>Kanban Overview &amp; Team Contributions</a:t>
             </a:r>
           </a:p>
         </p:txBody>
@@ -24118,7 +24133,7 @@
                   <a:srgbClr val="003A5D"/>
                 </a:solidFill>
               </a:rPr>
-              <a:t>Lucas: #44 to #50, 25 points</a:t>
+              <a:t>Lucas: #44 to #46, #48 to #50</a:t>
             </a:r>
           </a:p>
           <a:p>
@@ -24133,7 +24148,7 @@
                   <a:srgbClr val="003A5D"/>
                 </a:solidFill>
               </a:rPr>
-              <a:t>Genevieve: #36, 5 points, open</a:t>
+              <a:t>Caleb: #52, #55</a:t>
             </a:r>
           </a:p>
           <a:p>
@@ -24148,7 +24163,7 @@
                   <a:srgbClr val="003A5D"/>
                 </a:solidFill>
               </a:rPr>
-              <a:t>Caleb: add issues</a:t>
+              <a:t>Genevieve: #36, #53, #55</a:t>
             </a:r>
           </a:p>
           <a:p>
@@ -24163,7 +24178,7 @@
                   <a:srgbClr val="003A5D"/>
                 </a:solidFill>
               </a:rPr>
-              <a:t>Darron: add issues</a:t>
+              <a:t>Darron: &lt;placeholder&gt; #54, #55</a:t>
             </a:r>
           </a:p>
           <a:p>
@@ -24217,7 +24232,7 @@
           <a:lstStyle/>
           <a:p>
             <a:r>
-              <a:t>Evidence of client meetings</a:t>
+              <a:t>Evidence of MoM with Clients</a:t>
             </a:r>
           </a:p>
         </p:txBody>
@@ -24297,12 +24312,12 @@
               </a:spcAft>
             </a:pPr>
             <a:r>
-              <a:rPr sz="1800" b="1">
+              <a:rPr sz="1700" b="1">
                 <a:solidFill>
                   <a:srgbClr val="003A5D"/>
                 </a:solidFill>
               </a:rPr>
-              <a:t>Meeting 1 (planned agenda)</a:t>
+              <a:t>October 12, Go and C# comparison</a:t>
             </a:r>
           </a:p>
           <a:p>
@@ -24312,12 +24327,42 @@
               </a:spcAft>
             </a:pPr>
             <a:r>
-              <a:rPr sz="1600">
+              <a:rPr sz="1500">
                 <a:solidFill>
                   <a:srgbClr val="003A5D"/>
                 </a:solidFill>
               </a:rPr>
-              <a:t>Go and C# comparison, bridge hardening, demo app, request for a real Signal Hub</a:t>
+              <a:t>What Go makes hard: generics, callbacks, process ownership</a:t>
+            </a:r>
+          </a:p>
+          <a:p>
+            <a:pPr>
+              <a:spcAft>
+                <a:spcPts val="500"/>
+              </a:spcAft>
+            </a:pPr>
+            <a:r>
+              <a:rPr sz="1500">
+                <a:solidFill>
+                  <a:srgbClr val="003A5D"/>
+                </a:solidFill>
+              </a:rPr>
+              <a:t>Bridge hardening and the demo app</a:t>
+            </a:r>
+          </a:p>
+          <a:p>
+            <a:pPr>
+              <a:spcAft>
+                <a:spcPts val="500"/>
+              </a:spcAft>
+            </a:pPr>
+            <a:r>
+              <a:rPr sz="1500">
+                <a:solidFill>
+                  <a:srgbClr val="003A5D"/>
+                </a:solidFill>
+              </a:rPr>
+              <a:t>Open decisions and a real Signal Hub request</a:t>
             </a:r>
           </a:p>
         </p:txBody>
@@ -24368,12 +24413,12 @@
               </a:spcAft>
             </a:pPr>
             <a:r>
-              <a:rPr sz="1800" b="1">
+              <a:rPr sz="1700" b="1">
                 <a:solidFill>
                   <a:srgbClr val="003A5D"/>
                 </a:solidFill>
               </a:rPr>
-              <a:t>Meeting 2 (planned agenda)</a:t>
+              <a:t>October 26, Sprint 5 review</a:t>
             </a:r>
           </a:p>
           <a:p>
@@ -24383,12 +24428,42 @@
               </a:spcAft>
             </a:pPr>
             <a:r>
-              <a:rPr sz="1600">
+              <a:rPr sz="1500">
                 <a:solidFill>
                   <a:srgbClr val="003A5D"/>
                 </a:solidFill>
               </a:rPr>
-              <a:t>Python.NET spike, CI and compatibility, user guide, deployment needs, Sprint 6 plan</a:t>
+              <a:t>C# client still not available (#36)</a:t>
+            </a:r>
+          </a:p>
+          <a:p>
+            <a:pPr>
+              <a:spcAft>
+                <a:spcPts val="500"/>
+              </a:spcAft>
+            </a:pPr>
+            <a:r>
+              <a:rPr sz="1500">
+                <a:solidFill>
+                  <a:srgbClr val="003A5D"/>
+                </a:solidFill>
+              </a:rPr>
+              <a:t>Bindings, tests and CI status</a:t>
+            </a:r>
+          </a:p>
+          <a:p>
+            <a:pPr>
+              <a:spcAft>
+                <a:spcPts val="500"/>
+              </a:spcAft>
+            </a:pPr>
+            <a:r>
+              <a:rPr sz="1500">
+                <a:solidFill>
+                  <a:srgbClr val="003A5D"/>
+                </a:solidFill>
+              </a:rPr>
+              <a:t>Deployment needs and Sprint 6 plan</a:t>
             </a:r>
           </a:p>
         </p:txBody>
@@ -24427,7 +24502,7 @@
           <a:lstStyle/>
           <a:p>
             <a:r>
-              <a:t>Documentation of report</a:t>
+              <a:t>Documentation of Report</a:t>
             </a:r>
           </a:p>
         </p:txBody>
@@ -24527,7 +24602,7 @@
                   <a:srgbClr val="003A5D"/>
                 </a:solidFill>
               </a:rPr>
-              <a:t>Course template, deliverable status, testing tables</a:t>
+              <a:t>Course template sections and issue lists</a:t>
             </a:r>
           </a:p>
         </p:txBody>
@@ -24725,7 +24800,7 @@
                   <a:srgbClr val="003A5D"/>
                 </a:solidFill>
               </a:rPr>
-              <a:t>tests.yml and go.mod</a:t>
+              <a:t>Final report</a:t>
             </a:r>
           </a:p>
           <a:p>
@@ -24740,7 +24815,7 @@
                   <a:srgbClr val="003A5D"/>
                 </a:solidFill>
               </a:rPr>
-              <a:t>Real CI, COMTRADE builds on a fresh clone</a:t>
+              <a:t>New section V, test specifications and results</a:t>
             </a:r>
           </a:p>
         </p:txBody>
@@ -24850,7 +24925,7 @@
           <a:lstStyle/>
           <a:p>
             <a:r>
-              <a:t>Responsible use of GenAI</a:t>
+              <a:t>Responsible Use of AI</a:t>
             </a:r>
           </a:p>
         </p:txBody>
@@ -24936,7 +25011,7 @@
                   <a:srgbClr val="003A5D"/>
                 </a:solidFill>
               </a:rPr>
-              <a:t>Python.NET spike, its tests, and the CI workflow</a:t>
+              <a:t>Python.NET spike and its tests</a:t>
             </a:r>
           </a:p>
           <a:p>
@@ -25082,7 +25157,7 @@
                   <a:srgbClr val="003A5D"/>
                 </a:solidFill>
               </a:rPr>
-              <a:t>The old CI always passed. It is no longer used as evidence.</a:t>
+              <a:t>MoMs are written from AI transcripts and checked by the team.</a:t>
             </a:r>
           </a:p>
           <a:p>
@@ -25151,7 +25226,7 @@
           <a:lstStyle/>
           <a:p>
             <a:r>
-              <a:t>Achievements and challenges</a:t>
+              <a:t>Sprint Achievements and Challenges</a:t>
             </a:r>
           </a:p>
         </p:txBody>
@@ -25252,7 +25327,7 @@
                   <a:srgbClr val="003A5D"/>
                 </a:solidFill>
               </a:rPr>
-              <a:t>Real CI on two OSs and three Python versions</a:t>
+              <a:t>Team CI pipeline green on the Sprint 5 branch</a:t>
             </a:r>
           </a:p>
           <a:p>
@@ -25368,7 +25443,7 @@
                   <a:srgbClr val="003A5D"/>
                 </a:solidFill>
               </a:rPr>
-              <a:t>Private code cannot run in public CI. Public parts tested there.</a:t>
+              <a:t>SEL code is private. Results are shared, code is not.</a:t>
             </a:r>
           </a:p>
         </p:txBody>
@@ -25508,7 +25583,7 @@
           <a:lstStyle/>
           <a:p>
             <a:r>
-              <a:t>Next steps and retrospective</a:t>
+              <a:t>Next Steps and Sprint Retrospective</a:t>
             </a:r>
           </a:p>
         </p:txBody>
@@ -25973,7 +26048,7 @@
           <a:lstStyle/>
           <a:p>
             <a:r>
-              <a:t>Introduction and team roles</a:t>
+              <a:t>Introduction</a:t>
             </a:r>
           </a:p>
         </p:txBody>
@@ -26414,7 +26489,7 @@
                   <a:srgbClr val="003A5D"/>
                 </a:solidFill>
               </a:rPr>
-              <a:t>Cross-platform validation in the plan</a:t>
+              <a:t>&lt;placeholder&gt; Compatibility roadmap alignment &lt;/placeholder&gt;</a:t>
             </a:r>
           </a:p>
         </p:txBody>
@@ -26453,7 +26528,7 @@
           <a:lstStyle/>
           <a:p>
             <a:r>
-              <a:t>Sprint 5 objectives</a:t>
+              <a:t>Sprint Objectives</a:t>
             </a:r>
           </a:p>
         </p:txBody>
@@ -26948,7 +27023,7 @@
           <a:lstStyle/>
           <a:p>
             <a:r>
-              <a:t>Feature implementation</a:t>
+              <a:t>Feature Implementation and Demonstration</a:t>
             </a:r>
           </a:p>
         </p:txBody>
@@ -26978,7 +27053,7 @@
                 <a:gridCol w="2468880"/>
                 <a:gridCol w="1097280"/>
               </a:tblGrid>
-              <a:tr h="502920">
+              <a:tr h="402336">
                 <a:tc>
                   <a:txBody>
                     <a:bodyPr/>
@@ -27045,7 +27120,7 @@
                   <a:tcPr/>
                 </a:tc>
               </a:tr>
-              <a:tr h="502920">
+              <a:tr h="402336">
                 <a:tc>
                   <a:txBody>
                     <a:bodyPr/>
@@ -27112,7 +27187,7 @@
                   <a:tcPr/>
                 </a:tc>
               </a:tr>
-              <a:tr h="502920">
+              <a:tr h="402336">
                 <a:tc>
                   <a:txBody>
                     <a:bodyPr/>
@@ -27179,7 +27254,7 @@
                   <a:tcPr/>
                 </a:tc>
               </a:tr>
-              <a:tr h="502920">
+              <a:tr h="402336">
                 <a:tc>
                   <a:txBody>
                     <a:bodyPr/>
@@ -27246,74 +27321,7 @@
                   <a:tcPr/>
                 </a:tc>
               </a:tr>
-              <a:tr h="502920">
-                <a:tc>
-                  <a:txBody>
-                    <a:bodyPr/>
-                    <a:lstStyle/>
-                    <a:p>
-                      <a:r>
-                        <a:rPr sz="1500"/>
-                        <a:t>#47</a:t>
-                      </a:r>
-                    </a:p>
-                  </a:txBody>
-                  <a:tcPr/>
-                </a:tc>
-                <a:tc>
-                  <a:txBody>
-                    <a:bodyPr/>
-                    <a:lstStyle/>
-                    <a:p>
-                      <a:r>
-                        <a:rPr sz="1500"/>
-                        <a:t>CI that runs real tests</a:t>
-                      </a:r>
-                    </a:p>
-                  </a:txBody>
-                  <a:tcPr/>
-                </a:tc>
-                <a:tc>
-                  <a:txBody>
-                    <a:bodyPr/>
-                    <a:lstStyle/>
-                    <a:p>
-                      <a:r>
-                        <a:rPr sz="1500"/>
-                        <a:t>Lucas</a:t>
-                      </a:r>
-                    </a:p>
-                  </a:txBody>
-                  <a:tcPr/>
-                </a:tc>
-                <a:tc>
-                  <a:txBody>
-                    <a:bodyPr/>
-                    <a:lstStyle/>
-                    <a:p>
-                      <a:r>
-                        <a:rPr sz="1500"/>
-                        <a:t>In review</a:t>
-                      </a:r>
-                    </a:p>
-                  </a:txBody>
-                  <a:tcPr/>
-                </a:tc>
-                <a:tc>
-                  <a:txBody>
-                    <a:bodyPr/>
-                    <a:lstStyle/>
-                    <a:p>
-                      <a:r>
-                        <a:rPr sz="1500"/>
-                        <a:t>3</a:t>
-                      </a:r>
-                    </a:p>
-                  </a:txBody>
-                  <a:tcPr/>
-                </a:tc>
-              </a:tr>
-              <a:tr h="502920">
+              <a:tr h="402336">
                 <a:tc>
                   <a:txBody>
                     <a:bodyPr/>
@@ -27380,7 +27388,7 @@
                   <a:tcPr/>
                 </a:tc>
               </a:tr>
-              <a:tr h="502920">
+              <a:tr h="402336">
                 <a:tc>
                   <a:txBody>
                     <a:bodyPr/>
@@ -27447,7 +27455,74 @@
                   <a:tcPr/>
                 </a:tc>
               </a:tr>
-              <a:tr h="502920">
+              <a:tr h="402336">
+                <a:tc>
+                  <a:txBody>
+                    <a:bodyPr/>
+                    <a:lstStyle/>
+                    <a:p>
+                      <a:r>
+                        <a:rPr sz="1500"/>
+                        <a:t>#52</a:t>
+                      </a:r>
+                    </a:p>
+                  </a:txBody>
+                  <a:tcPr/>
+                </a:tc>
+                <a:tc>
+                  <a:txBody>
+                    <a:bodyPr/>
+                    <a:lstStyle/>
+                    <a:p>
+                      <a:r>
+                        <a:rPr sz="1500"/>
+                        <a:t>Test harness CI evidence</a:t>
+                      </a:r>
+                    </a:p>
+                  </a:txBody>
+                  <a:tcPr/>
+                </a:tc>
+                <a:tc>
+                  <a:txBody>
+                    <a:bodyPr/>
+                    <a:lstStyle/>
+                    <a:p>
+                      <a:r>
+                        <a:rPr sz="1500"/>
+                        <a:t>Caleb</a:t>
+                      </a:r>
+                    </a:p>
+                  </a:txBody>
+                  <a:tcPr/>
+                </a:tc>
+                <a:tc>
+                  <a:txBody>
+                    <a:bodyPr/>
+                    <a:lstStyle/>
+                    <a:p>
+                      <a:r>
+                        <a:rPr sz="1500"/>
+                        <a:t>In progress</a:t>
+                      </a:r>
+                    </a:p>
+                  </a:txBody>
+                  <a:tcPr/>
+                </a:tc>
+                <a:tc>
+                  <a:txBody>
+                    <a:bodyPr/>
+                    <a:lstStyle/>
+                    <a:p>
+                      <a:r>
+                        <a:rPr sz="1500"/>
+                        <a:t>2</a:t>
+                      </a:r>
+                    </a:p>
+                  </a:txBody>
+                  <a:tcPr/>
+                </a:tc>
+              </a:tr>
+              <a:tr h="402336">
                 <a:tc>
                   <a:txBody>
                     <a:bodyPr/>
@@ -27514,6 +27589,140 @@
                   <a:tcPr/>
                 </a:tc>
               </a:tr>
+              <a:tr h="402336">
+                <a:tc>
+                  <a:txBody>
+                    <a:bodyPr/>
+                    <a:lstStyle/>
+                    <a:p>
+                      <a:r>
+                        <a:rPr sz="1500"/>
+                        <a:t>#53</a:t>
+                      </a:r>
+                    </a:p>
+                  </a:txBody>
+                  <a:tcPr/>
+                </a:tc>
+                <a:tc>
+                  <a:txBody>
+                    <a:bodyPr/>
+                    <a:lstStyle/>
+                    <a:p>
+                      <a:r>
+                        <a:rPr sz="1500"/>
+                        <a:t>User guide review</a:t>
+                      </a:r>
+                    </a:p>
+                  </a:txBody>
+                  <a:tcPr/>
+                </a:tc>
+                <a:tc>
+                  <a:txBody>
+                    <a:bodyPr/>
+                    <a:lstStyle/>
+                    <a:p>
+                      <a:r>
+                        <a:rPr sz="1500"/>
+                        <a:t>Genevieve</a:t>
+                      </a:r>
+                    </a:p>
+                  </a:txBody>
+                  <a:tcPr/>
+                </a:tc>
+                <a:tc>
+                  <a:txBody>
+                    <a:bodyPr/>
+                    <a:lstStyle/>
+                    <a:p>
+                      <a:r>
+                        <a:rPr sz="1500"/>
+                        <a:t>Ready</a:t>
+                      </a:r>
+                    </a:p>
+                  </a:txBody>
+                  <a:tcPr/>
+                </a:tc>
+                <a:tc>
+                  <a:txBody>
+                    <a:bodyPr/>
+                    <a:lstStyle/>
+                    <a:p>
+                      <a:r>
+                        <a:rPr sz="1500"/>
+                        <a:t>2</a:t>
+                      </a:r>
+                    </a:p>
+                  </a:txBody>
+                  <a:tcPr/>
+                </a:tc>
+              </a:tr>
+              <a:tr h="402336">
+                <a:tc>
+                  <a:txBody>
+                    <a:bodyPr/>
+                    <a:lstStyle/>
+                    <a:p>
+                      <a:r>
+                        <a:rPr sz="1500"/>
+                        <a:t>#54</a:t>
+                      </a:r>
+                    </a:p>
+                  </a:txBody>
+                  <a:tcPr/>
+                </a:tc>
+                <a:tc>
+                  <a:txBody>
+                    <a:bodyPr/>
+                    <a:lstStyle/>
+                    <a:p>
+                      <a:r>
+                        <a:rPr sz="1500"/>
+                        <a:t>&lt;placeholder&gt; Compatibility roadmap alignment</a:t>
+                      </a:r>
+                    </a:p>
+                  </a:txBody>
+                  <a:tcPr/>
+                </a:tc>
+                <a:tc>
+                  <a:txBody>
+                    <a:bodyPr/>
+                    <a:lstStyle/>
+                    <a:p>
+                      <a:r>
+                        <a:rPr sz="1500"/>
+                        <a:t>Darron</a:t>
+                      </a:r>
+                    </a:p>
+                  </a:txBody>
+                  <a:tcPr/>
+                </a:tc>
+                <a:tc>
+                  <a:txBody>
+                    <a:bodyPr/>
+                    <a:lstStyle/>
+                    <a:p>
+                      <a:r>
+                        <a:rPr sz="1500"/>
+                        <a:t>&lt;placeholder&gt;</a:t>
+                      </a:r>
+                    </a:p>
+                  </a:txBody>
+                  <a:tcPr/>
+                </a:tc>
+                <a:tc>
+                  <a:txBody>
+                    <a:bodyPr/>
+                    <a:lstStyle/>
+                    <a:p>
+                      <a:r>
+                        <a:rPr sz="1500"/>
+                        <a:t>3</a:t>
+                      </a:r>
+                    </a:p>
+                  </a:txBody>
+                  <a:tcPr/>
+                </a:tc>
+              </a:tr>
             </a:tbl>
           </a:graphicData>
         </a:graphic>
@@ -27590,7 +27799,7 @@
           <a:lstStyle/>
           <a:p>
             <a:r>
-              <a:t>Bridge hardening and crash recovery</a:t>
+              <a:t>Feature: Bridge Crash Recovery</a:t>
             </a:r>
           </a:p>
         </p:txBody>
@@ -28093,7 +28302,7 @@
           <a:lstStyle/>
           <a:p>
             <a:r>
-              <a:t>Demo: publish and subscribe from Python</a:t>
+              <a:t>Demo: Publish and Subscribe from Python</a:t>
             </a:r>
           </a:p>
         </p:txBody>
@@ -28363,7 +28572,7 @@
           <a:lstStyle/>
           <a:p>
             <a:r>
-              <a:t>Python.NET spike results</a:t>
+              <a:t>Feature: Python.NET Spike</a:t>
             </a:r>
           </a:p>
         </p:txBody>
@@ -28700,7 +28909,7 @@
               </a:spcAft>
             </a:pPr>
             <a:r>
-              <a:rPr sz="1600" b="1">
+              <a:rPr sz="1800" b="1">
                 <a:solidFill>
                   <a:srgbClr val="003A5D"/>
                 </a:solidFill>
@@ -28715,7 +28924,7 @@
               </a:spcAft>
             </a:pPr>
             <a:r>
-              <a:rPr sz="1400">
+              <a:rPr sz="1600">
                 <a:solidFill>
                   <a:srgbClr val="003A5D"/>
                 </a:solidFill>
@@ -28730,7 +28939,7 @@
               </a:spcAft>
             </a:pPr>
             <a:r>
-              <a:rPr sz="1400">
+              <a:rPr sz="1600">
                 <a:solidFill>
                   <a:srgbClr val="003A5D"/>
                 </a:solidFill>
@@ -28774,7 +28983,7 @@
           <a:lstStyle/>
           <a:p>
             <a:r>
-              <a:t>Deployment path to Blueframe</a:t>
+              <a:t>Deployment of the System</a:t>
             </a:r>
           </a:p>
         </p:txBody>
@@ -28825,7 +29034,7 @@
               </a:spcAft>
             </a:pPr>
             <a:r>
-              <a:rPr sz="1600" b="1">
+              <a:rPr sz="1800" b="1">
                 <a:solidFill>
                   <a:srgbClr val="003A5D"/>
                 </a:solidFill>
@@ -28840,7 +29049,7 @@
               </a:spcAft>
             </a:pPr>
             <a:r>
-              <a:rPr sz="1400">
+              <a:rPr sz="1600">
                 <a:solidFill>
                   <a:srgbClr val="003A5D"/>
                 </a:solidFill>
@@ -28855,7 +29064,7 @@
               </a:spcAft>
             </a:pPr>
             <a:r>
-              <a:rPr sz="1400">
+              <a:rPr sz="1600">
                 <a:solidFill>
                   <a:srgbClr val="003A5D"/>
                 </a:solidFill>
@@ -28911,7 +29120,7 @@
               </a:spcAft>
             </a:pPr>
             <a:r>
-              <a:rPr sz="1600" b="1">
+              <a:rPr sz="1800" b="1">
                 <a:solidFill>
                   <a:srgbClr val="003A5D"/>
                 </a:solidFill>
@@ -28926,7 +29135,7 @@
               </a:spcAft>
             </a:pPr>
             <a:r>
-              <a:rPr sz="1400">
+              <a:rPr sz="1600">
                 <a:solidFill>
                   <a:srgbClr val="003A5D"/>
                 </a:solidFill>
@@ -28941,7 +29150,7 @@
               </a:spcAft>
             </a:pPr>
             <a:r>
-              <a:rPr sz="1400">
+              <a:rPr sz="1600">
                 <a:solidFill>
                   <a:srgbClr val="003A5D"/>
                 </a:solidFill>
@@ -28997,7 +29206,7 @@
               </a:spcAft>
             </a:pPr>
             <a:r>
-              <a:rPr sz="1600" b="1">
+              <a:rPr sz="1800" b="1">
                 <a:solidFill>
                   <a:srgbClr val="003A5D"/>
                 </a:solidFill>
@@ -29012,7 +29221,7 @@
               </a:spcAft>
             </a:pPr>
             <a:r>
-              <a:rPr sz="1400">
+              <a:rPr sz="1600">
                 <a:solidFill>
                   <a:srgbClr val="003A5D"/>
                 </a:solidFill>
@@ -29027,7 +29236,7 @@
               </a:spcAft>
             </a:pPr>
             <a:r>
-              <a:rPr sz="1400">
+              <a:rPr sz="1600">
                 <a:solidFill>
                   <a:srgbClr val="003A5D"/>
                 </a:solidFill>
@@ -29083,7 +29292,7 @@
               </a:spcAft>
             </a:pPr>
             <a:r>
-              <a:rPr sz="1600" b="1">
+              <a:rPr sz="1800" b="1">
                 <a:solidFill>
                   <a:srgbClr val="003A5D"/>
                 </a:solidFill>
@@ -29098,7 +29307,7 @@
               </a:spcAft>
             </a:pPr>
             <a:r>
-              <a:rPr sz="1400">
+              <a:rPr sz="1600">
                 <a:solidFill>
                   <a:srgbClr val="003A5D"/>
                 </a:solidFill>
@@ -29113,7 +29322,7 @@
               </a:spcAft>
             </a:pPr>
             <a:r>
-              <a:rPr sz="1400">
+              <a:rPr sz="1600">
                 <a:solidFill>
                   <a:srgbClr val="003A5D"/>
                 </a:solidFill>
@@ -29228,14 +29437,14 @@
           <a:lstStyle/>
           <a:p>
             <a:r>
-              <a:t>CI and compatibility</a:t>
+              <a:t>Deployment: CI/CD and Compatibility</a:t>
             </a:r>
           </a:p>
         </p:txBody>
       </p:sp>
       <p:pic>
         <p:nvPicPr>
-          <p:cNvPr id="3" name="Picture 2" descr="ci_jobs_clean.png"/>
+          <p:cNvPr id="3" name="Picture 2" descr="ci_old_jobs.png"/>
           <p:cNvPicPr>
             <a:picLocks noChangeAspect="1"/>
           </p:cNvPicPr>
@@ -29250,7 +29459,7 @@
         <p:spPr>
           <a:xfrm>
             <a:off x="658368" y="1737360"/>
-            <a:ext cx="6766560" cy="3881646"/>
+            <a:ext cx="6617638" cy="4389120"/>
           </a:xfrm>
           <a:prstGeom prst="rect">
             <a:avLst/>
@@ -29343,7 +29552,7 @@
                   <a:srgbClr val="003A5D"/>
                 </a:solidFill>
               </a:rPr>
-              <a:t>Python.NET: 3.10, 3.12, 3.13 on Linux and Windows, all pass.</a:t>
+              <a:t>Python.NET spike: 6 tests pass on Linux and Windows, Python 3.10, 3.12, 3.13.</a:t>
             </a:r>
           </a:p>
           <a:p>
@@ -29358,7 +29567,7 @@
                   <a:srgbClr val="003A5D"/>
                 </a:solidFill>
               </a:rPr>
-              <a:t>COMTRADE: Go 1.21 and stable on Linux and Windows, all pass.</a:t>
+              <a:t>Team pipeline: Go 1.21, 1.22, 1.23.</a:t>
             </a:r>
           </a:p>
           <a:p>

</xml_diff>

<commit_message>
Update Darron's Sprint 5 items
</commit_message>
<xml_diff>
--- a/Sprints/Sprint_5/Sprint 5 Presentation.pptx
+++ b/Sprints/Sprint_5/Sprint 5 Presentation.pptx
@@ -1993,7 +1993,7 @@
           </a:p>
           <a:p>
             <a:r>
-              <a:t>Each member names their features and issues. Caleb shows the team CI run (#52), Genevieve the C# evaluation status and the user guide (#36, #53), Darron &lt;placeholder&gt;. Lucas demos the bridge, the pub/sub example, and the Python.NET spike on the next slides.</a:t>
+              <a:t>Each member names their features and issues. Caleb shows the team CI run (#52), Genevieve the C# evaluation status and the user guide (#36, #53), Darron the compatibility roadmap (#54). Lucas demos the bridge, the pub/sub example, and the Python.NET spike on the next slides.</a:t>
             </a:r>
           </a:p>
         </p:txBody>
@@ -24178,7 +24178,7 @@
                   <a:srgbClr val="003A5D"/>
                 </a:solidFill>
               </a:rPr>
-              <a:t>Darron: &lt;placeholder&gt; #54, #55</a:t>
+              <a:t>Darron: #54, #55</a:t>
             </a:r>
           </a:p>
           <a:p>
@@ -26489,7 +26489,7 @@
                   <a:srgbClr val="003A5D"/>
                 </a:solidFill>
               </a:rPr>
-              <a:t>&lt;placeholder&gt; Compatibility roadmap alignment &lt;/placeholder&gt;</a:t>
+              <a:t>Cross-platform validation and compatibility roadmap</a:t>
             </a:r>
           </a:p>
         </p:txBody>
@@ -27677,7 +27677,7 @@
                     <a:p>
                       <a:r>
                         <a:rPr sz="1500"/>
-                        <a:t>&lt;placeholder&gt; Compatibility roadmap alignment</a:t>
+                        <a:t>Cross-platform compatibility roadmap</a:t>
                       </a:r>
                     </a:p>
                   </a:txBody>
@@ -27703,7 +27703,7 @@
                     <a:p>
                       <a:r>
                         <a:rPr sz="1500"/>
-                        <a:t>&lt;placeholder&gt;</a:t>
+                        <a:t>Ready</a:t>
                       </a:r>
                     </a:p>
                   </a:txBody>

</xml_diff>

<commit_message>
Mark #52 to #54 complete in Sprint 5 report and slides
</commit_message>
<xml_diff>
--- a/Sprints/Sprint_5/Sprint 5 Presentation.pptx
+++ b/Sprints/Sprint_5/Sprint 5 Presentation.pptx
@@ -1318,7 +1318,7 @@
           </a:p>
           <a:p>
             <a:r>
-              <a:t>Show the board. Done has #44 and #45, In review has #46, #48 to #50 and PR #51, In progress has #52, Ready has #36, #53, #54 and #55. Each member names their issues.</a:t>
+              <a:t>Show the board. Done has #44, #45 and #52 to #54, In review has #46, #48 to #50 and PR #51, Ready has #36 and #55. Each member names their issues.</a:t>
             </a:r>
           </a:p>
         </p:txBody>
@@ -27502,7 +27502,7 @@
                     <a:p>
                       <a:r>
                         <a:rPr sz="1500"/>
-                        <a:t>In progress</a:t>
+                        <a:t>Done</a:t>
                       </a:r>
                     </a:p>
                   </a:txBody>
@@ -27636,7 +27636,7 @@
                     <a:p>
                       <a:r>
                         <a:rPr sz="1500"/>
-                        <a:t>Ready</a:t>
+                        <a:t>Done</a:t>
                       </a:r>
                     </a:p>
                   </a:txBody>
@@ -27703,7 +27703,7 @@
                     <a:p>
                       <a:r>
                         <a:rPr sz="1500"/>
-                        <a:t>Ready</a:t>
+                        <a:t>Done</a:t>
                       </a:r>
                     </a:p>
                   </a:txBody>

</xml_diff>

<commit_message>
Remove SEL logo from slides other than the title
</commit_message>
<xml_diff>
--- a/Sprints/Sprint_5/Sprint 5 Presentation.pptx
+++ b/Sprints/Sprint_5/Sprint 5 Presentation.pptx
@@ -2746,36 +2746,6 @@
           </a:p>
         </p:txBody>
       </p:sp>
-      <p:pic>
-        <p:nvPicPr>
-          <p:cNvPr id="9" name="SEL_Monogram">
-            <a:extLst>
-              <a:ext uri="{FF2B5EF4-FFF2-40B4-BE49-F238E27FC236}">
-                <a16:creationId xmlns:a16="http://schemas.microsoft.com/office/drawing/2014/main" id="{20B3D8BE-242F-4C8E-A7F9-9F35D6B9D55A}"/>
-              </a:ext>
-            </a:extLst>
-          </p:cNvPr>
-          <p:cNvPicPr>
-            <a:picLocks noChangeAspect="1"/>
-          </p:cNvPicPr>
-          <p:nvPr/>
-        </p:nvPicPr>
-        <p:blipFill>
-          <a:blip r:embed="rId2"/>
-          <a:stretch>
-            <a:fillRect/>
-          </a:stretch>
-        </p:blipFill>
-        <p:spPr>
-          <a:xfrm>
-            <a:off x="660400" y="3959241"/>
-            <a:ext cx="902286" cy="518205"/>
-          </a:xfrm>
-          <a:prstGeom prst="rect">
-            <a:avLst/>
-          </a:prstGeom>
-        </p:spPr>
-      </p:pic>
       <p:sp>
         <p:nvSpPr>
           <p:cNvPr id="2" name="Title 1">
@@ -4569,36 +4539,6 @@
           </a:p>
         </p:txBody>
       </p:sp>
-      <p:pic>
-        <p:nvPicPr>
-          <p:cNvPr id="10" name="SEL_Monogram">
-            <a:extLst>
-              <a:ext uri="{FF2B5EF4-FFF2-40B4-BE49-F238E27FC236}">
-                <a16:creationId xmlns:a16="http://schemas.microsoft.com/office/drawing/2014/main" id="{2FC75D82-BBD9-5710-C18E-F7F993C26A72}"/>
-              </a:ext>
-            </a:extLst>
-          </p:cNvPr>
-          <p:cNvPicPr>
-            <a:picLocks noChangeAspect="1"/>
-          </p:cNvPicPr>
-          <p:nvPr/>
-        </p:nvPicPr>
-        <p:blipFill>
-          <a:blip r:embed="rId2"/>
-          <a:stretch>
-            <a:fillRect/>
-          </a:stretch>
-        </p:blipFill>
-        <p:spPr>
-          <a:xfrm>
-            <a:off x="660400" y="3959241"/>
-            <a:ext cx="902286" cy="518205"/>
-          </a:xfrm>
-          <a:prstGeom prst="rect">
-            <a:avLst/>
-          </a:prstGeom>
-        </p:spPr>
-      </p:pic>
     </p:spTree>
     <p:extLst>
       <p:ext uri="{BB962C8B-B14F-4D97-AF65-F5344CB8AC3E}">
@@ -6018,36 +5958,6 @@
           </a:p>
         </p:txBody>
       </p:sp>
-      <p:pic>
-        <p:nvPicPr>
-          <p:cNvPr id="30" name="SEL_Monogram">
-            <a:extLst>
-              <a:ext uri="{FF2B5EF4-FFF2-40B4-BE49-F238E27FC236}">
-                <a16:creationId xmlns:a16="http://schemas.microsoft.com/office/drawing/2014/main" id="{3180C2C0-CBE9-43BC-AEC1-A5921CCA1996}"/>
-              </a:ext>
-            </a:extLst>
-          </p:cNvPr>
-          <p:cNvPicPr>
-            <a:picLocks noChangeAspect="1"/>
-          </p:cNvPicPr>
-          <p:nvPr/>
-        </p:nvPicPr>
-        <p:blipFill>
-          <a:blip r:embed="rId2"/>
-          <a:stretch>
-            <a:fillRect/>
-          </a:stretch>
-        </p:blipFill>
-        <p:spPr>
-          <a:xfrm>
-            <a:off x="660400" y="2224996"/>
-            <a:ext cx="902286" cy="518205"/>
-          </a:xfrm>
-          <a:prstGeom prst="rect">
-            <a:avLst/>
-          </a:prstGeom>
-        </p:spPr>
-      </p:pic>
       <p:sp>
         <p:nvSpPr>
           <p:cNvPr id="2" name="Title 1">
@@ -6654,36 +6564,6 @@
           </a:p>
         </p:txBody>
       </p:sp>
-      <p:pic>
-        <p:nvPicPr>
-          <p:cNvPr id="7" name="SEL_Monogram">
-            <a:extLst>
-              <a:ext uri="{FF2B5EF4-FFF2-40B4-BE49-F238E27FC236}">
-                <a16:creationId xmlns:a16="http://schemas.microsoft.com/office/drawing/2014/main" id="{3180C2C0-CBE9-43BC-AEC1-A5921CCA1996}"/>
-              </a:ext>
-            </a:extLst>
-          </p:cNvPr>
-          <p:cNvPicPr>
-            <a:picLocks noChangeAspect="1"/>
-          </p:cNvPicPr>
-          <p:nvPr userDrawn="1"/>
-        </p:nvPicPr>
-        <p:blipFill>
-          <a:blip r:embed="rId2"/>
-          <a:stretch>
-            <a:fillRect/>
-          </a:stretch>
-        </p:blipFill>
-        <p:spPr>
-          <a:xfrm>
-            <a:off x="660400" y="1577636"/>
-            <a:ext cx="902286" cy="518205"/>
-          </a:xfrm>
-          <a:prstGeom prst="rect">
-            <a:avLst/>
-          </a:prstGeom>
-        </p:spPr>
-      </p:pic>
       <p:sp>
         <p:nvSpPr>
           <p:cNvPr id="2" name="Title 1">
@@ -7304,36 +7184,6 @@
           </a:p>
         </p:txBody>
       </p:sp>
-      <p:pic>
-        <p:nvPicPr>
-          <p:cNvPr id="11" name="SEL_Monogram">
-            <a:extLst>
-              <a:ext uri="{FF2B5EF4-FFF2-40B4-BE49-F238E27FC236}">
-                <a16:creationId xmlns:a16="http://schemas.microsoft.com/office/drawing/2014/main" id="{93C13453-FA11-4E3F-A2DC-3EC54E2D6712}"/>
-              </a:ext>
-            </a:extLst>
-          </p:cNvPr>
-          <p:cNvPicPr>
-            <a:picLocks noChangeAspect="1"/>
-          </p:cNvPicPr>
-          <p:nvPr/>
-        </p:nvPicPr>
-        <p:blipFill>
-          <a:blip r:embed="rId2"/>
-          <a:stretch>
-            <a:fillRect/>
-          </a:stretch>
-        </p:blipFill>
-        <p:spPr>
-          <a:xfrm>
-            <a:off x="660400" y="3959242"/>
-            <a:ext cx="902286" cy="518205"/>
-          </a:xfrm>
-          <a:prstGeom prst="rect">
-            <a:avLst/>
-          </a:prstGeom>
-        </p:spPr>
-      </p:pic>
       <p:sp>
         <p:nvSpPr>
           <p:cNvPr id="6" name="Title 5">
@@ -7471,36 +7321,6 @@
           </a:p>
         </p:txBody>
       </p:sp>
-      <p:pic>
-        <p:nvPicPr>
-          <p:cNvPr id="13" name="SEL_Monogram">
-            <a:extLst>
-              <a:ext uri="{FF2B5EF4-FFF2-40B4-BE49-F238E27FC236}">
-                <a16:creationId xmlns:a16="http://schemas.microsoft.com/office/drawing/2014/main" id="{DB63A8B2-014A-F4D1-8664-021BB3B5946A}"/>
-              </a:ext>
-            </a:extLst>
-          </p:cNvPr>
-          <p:cNvPicPr>
-            <a:picLocks noChangeAspect="1"/>
-          </p:cNvPicPr>
-          <p:nvPr/>
-        </p:nvPicPr>
-        <p:blipFill>
-          <a:blip r:embed="rId2"/>
-          <a:stretch>
-            <a:fillRect/>
-          </a:stretch>
-        </p:blipFill>
-        <p:spPr>
-          <a:xfrm>
-            <a:off x="660400" y="3253694"/>
-            <a:ext cx="902286" cy="518205"/>
-          </a:xfrm>
-          <a:prstGeom prst="rect">
-            <a:avLst/>
-          </a:prstGeom>
-        </p:spPr>
-      </p:pic>
       <p:sp>
         <p:nvSpPr>
           <p:cNvPr id="7" name="Text Placeholder 6">
@@ -8820,36 +8640,6 @@
           </a:p>
         </p:txBody>
       </p:sp>
-      <p:pic>
-        <p:nvPicPr>
-          <p:cNvPr id="10" name="SEL_Monogram">
-            <a:extLst>
-              <a:ext uri="{FF2B5EF4-FFF2-40B4-BE49-F238E27FC236}">
-                <a16:creationId xmlns:a16="http://schemas.microsoft.com/office/drawing/2014/main" id="{13073BA1-1426-D562-8E9D-06174B4878EF}"/>
-              </a:ext>
-            </a:extLst>
-          </p:cNvPr>
-          <p:cNvPicPr>
-            <a:picLocks noChangeAspect="1"/>
-          </p:cNvPicPr>
-          <p:nvPr userDrawn="1"/>
-        </p:nvPicPr>
-        <p:blipFill>
-          <a:blip r:embed="rId2"/>
-          <a:stretch>
-            <a:fillRect/>
-          </a:stretch>
-        </p:blipFill>
-        <p:spPr>
-          <a:xfrm>
-            <a:off x="660400" y="2224996"/>
-            <a:ext cx="902286" cy="518205"/>
-          </a:xfrm>
-          <a:prstGeom prst="rect">
-            <a:avLst/>
-          </a:prstGeom>
-        </p:spPr>
-      </p:pic>
       <p:sp>
         <p:nvSpPr>
           <p:cNvPr id="3" name="SEL_Copyright">
@@ -19844,44 +19634,6 @@
           </a:p>
         </p:txBody>
       </p:sp>
-      <p:pic>
-        <p:nvPicPr>
-          <p:cNvPr id="8" name="SEL_Logo">
-            <a:extLst>
-              <a:ext uri="{FF2B5EF4-FFF2-40B4-BE49-F238E27FC236}">
-                <a16:creationId xmlns:a16="http://schemas.microsoft.com/office/drawing/2014/main" id="{C1C72DEA-9441-457D-9FD2-FCD6AE563176}"/>
-              </a:ext>
-              <a:ext uri="{C183D7F6-B498-43B3-948B-1728B52AA6E4}">
-                <adec:decorative xmlns:adec="http://schemas.microsoft.com/office/drawing/2017/decorative" val="1"/>
-              </a:ext>
-            </a:extLst>
-          </p:cNvPr>
-          <p:cNvPicPr>
-            <a:picLocks noChangeAspect="1"/>
-          </p:cNvPicPr>
-          <p:nvPr/>
-        </p:nvPicPr>
-        <p:blipFill rotWithShape="1">
-          <a:blip r:embed="rId2" cstate="screen">
-            <a:extLst>
-              <a:ext uri="{28A0092B-C50C-407E-A947-70E740481C1C}">
-                <a14:useLocalDpi xmlns:a14="http://schemas.microsoft.com/office/drawing/2010/main"/>
-              </a:ext>
-            </a:extLst>
-          </a:blip>
-          <a:srcRect l="5118" r="5556"/>
-          <a:stretch/>
-        </p:blipFill>
-        <p:spPr>
-          <a:xfrm>
-            <a:off x="664536" y="5640956"/>
-            <a:ext cx="2415737" cy="579511"/>
-          </a:xfrm>
-          <a:prstGeom prst="rect">
-            <a:avLst/>
-          </a:prstGeom>
-        </p:spPr>
-      </p:pic>
       <p:sp>
         <p:nvSpPr>
           <p:cNvPr id="3" name="White_SEL_Confidential" hidden="1">
@@ -20072,44 +19824,6 @@
           </a:p>
         </p:txBody>
       </p:sp>
-      <p:pic>
-        <p:nvPicPr>
-          <p:cNvPr id="8" name="SEL_Logo">
-            <a:extLst>
-              <a:ext uri="{FF2B5EF4-FFF2-40B4-BE49-F238E27FC236}">
-                <a16:creationId xmlns:a16="http://schemas.microsoft.com/office/drawing/2014/main" id="{6AD9D9ED-9067-4792-B745-CBBB4B2D3DE8}"/>
-              </a:ext>
-              <a:ext uri="{C183D7F6-B498-43B3-948B-1728B52AA6E4}">
-                <adec:decorative xmlns:adec="http://schemas.microsoft.com/office/drawing/2017/decorative" val="1"/>
-              </a:ext>
-            </a:extLst>
-          </p:cNvPr>
-          <p:cNvPicPr>
-            <a:picLocks noChangeAspect="1"/>
-          </p:cNvPicPr>
-          <p:nvPr/>
-        </p:nvPicPr>
-        <p:blipFill rotWithShape="1">
-          <a:blip r:embed="rId2" cstate="screen">
-            <a:extLst>
-              <a:ext uri="{28A0092B-C50C-407E-A947-70E740481C1C}">
-                <a14:useLocalDpi xmlns:a14="http://schemas.microsoft.com/office/drawing/2010/main"/>
-              </a:ext>
-            </a:extLst>
-          </a:blip>
-          <a:srcRect l="5118" r="5556"/>
-          <a:stretch/>
-        </p:blipFill>
-        <p:spPr>
-          <a:xfrm>
-            <a:off x="664536" y="5640956"/>
-            <a:ext cx="2415737" cy="579511"/>
-          </a:xfrm>
-          <a:prstGeom prst="rect">
-            <a:avLst/>
-          </a:prstGeom>
-        </p:spPr>
-      </p:pic>
       <p:sp>
         <p:nvSpPr>
           <p:cNvPr id="9" name="Thank_You">
@@ -20275,42 +19989,6 @@
           </a:p>
         </p:txBody>
       </p:sp>
-      <p:pic>
-        <p:nvPicPr>
-          <p:cNvPr id="3" name="SEL_Logo_White">
-            <a:extLst>
-              <a:ext uri="{FF2B5EF4-FFF2-40B4-BE49-F238E27FC236}">
-                <a16:creationId xmlns:a16="http://schemas.microsoft.com/office/drawing/2014/main" id="{203DFEB5-540A-DF93-6752-44A50F11E050}"/>
-              </a:ext>
-            </a:extLst>
-          </p:cNvPr>
-          <p:cNvPicPr>
-            <a:picLocks noChangeAspect="1"/>
-          </p:cNvPicPr>
-          <p:nvPr/>
-        </p:nvPicPr>
-        <p:blipFill>
-          <a:blip r:embed="rId2">
-            <a:extLst>
-              <a:ext uri="{28A0092B-C50C-407E-A947-70E740481C1C}">
-                <a14:useLocalDpi xmlns:a14="http://schemas.microsoft.com/office/drawing/2010/main" val="0"/>
-              </a:ext>
-            </a:extLst>
-          </a:blip>
-          <a:stretch>
-            <a:fillRect/>
-          </a:stretch>
-        </p:blipFill>
-        <p:spPr>
-          <a:xfrm>
-            <a:off x="450015" y="5437056"/>
-            <a:ext cx="2804318" cy="961881"/>
-          </a:xfrm>
-          <a:prstGeom prst="rect">
-            <a:avLst/>
-          </a:prstGeom>
-        </p:spPr>
-      </p:pic>
       <p:sp>
         <p:nvSpPr>
           <p:cNvPr id="9" name="Thank_You">
@@ -20439,44 +20117,6 @@
           </a:p>
         </p:txBody>
       </p:sp>
-      <p:pic>
-        <p:nvPicPr>
-          <p:cNvPr id="7" name="SEL_Logo">
-            <a:extLst>
-              <a:ext uri="{FF2B5EF4-FFF2-40B4-BE49-F238E27FC236}">
-                <a16:creationId xmlns:a16="http://schemas.microsoft.com/office/drawing/2014/main" id="{C84DBC4C-0D90-B611-34F4-B2BBFCECC38B}"/>
-              </a:ext>
-              <a:ext uri="{C183D7F6-B498-43B3-948B-1728B52AA6E4}">
-                <adec:decorative xmlns:adec="http://schemas.microsoft.com/office/drawing/2017/decorative" val="1"/>
-              </a:ext>
-            </a:extLst>
-          </p:cNvPr>
-          <p:cNvPicPr>
-            <a:picLocks noChangeAspect="1"/>
-          </p:cNvPicPr>
-          <p:nvPr userDrawn="1"/>
-        </p:nvPicPr>
-        <p:blipFill rotWithShape="1">
-          <a:blip r:embed="rId2" cstate="screen">
-            <a:extLst>
-              <a:ext uri="{28A0092B-C50C-407E-A947-70E740481C1C}">
-                <a14:useLocalDpi xmlns:a14="http://schemas.microsoft.com/office/drawing/2010/main"/>
-              </a:ext>
-            </a:extLst>
-          </a:blip>
-          <a:srcRect l="5118" r="5556"/>
-          <a:stretch/>
-        </p:blipFill>
-        <p:spPr>
-          <a:xfrm>
-            <a:off x="664536" y="5640957"/>
-            <a:ext cx="2415737" cy="579511"/>
-          </a:xfrm>
-          <a:prstGeom prst="rect">
-            <a:avLst/>
-          </a:prstGeom>
-        </p:spPr>
-      </p:pic>
       <p:sp>
         <p:nvSpPr>
           <p:cNvPr id="13" name="Text Placeholder 12">

</xml_diff>

<commit_message>
Rewrite Sprint 5 slide text and notes
</commit_message>
<xml_diff>
--- a/Sprints/Sprint_5/Sprint 5 Presentation.pptx
+++ b/Sprints/Sprint_5/Sprint 5 Presentation.pptx
@@ -1163,12 +1163,12 @@
           <a:lstStyle/>
           <a:p>
             <a:r>
-              <a:t>Presenter: Lucas Phillips. About 15 seconds.</a:t>
-            </a:r>
-          </a:p>
-          <a:p>
-            <a:r>
-              <a:t>Say the project name, the course, and that this is the Sprint 5 walkthrough. Each section is presented by a different person.</a:t>
+              <a:t>Lucas Phillips presents this slide, about 15 seconds.</a:t>
+            </a:r>
+          </a:p>
+          <a:p>
+            <a:r>
+              <a:t>Say the project name and the course, and that this is the Sprint 5 walkthrough. Each section is presented by a different person.</a:t>
             </a:r>
           </a:p>
         </p:txBody>
@@ -1238,12 +1238,12 @@
           <a:lstStyle/>
           <a:p>
             <a:r>
-              <a:t>Presenter: Genevieve Kochel. About 45 seconds.</a:t>
-            </a:r>
-          </a:p>
-          <a:p>
-            <a:r>
-              <a:t>Integration and system tests run the real SDK against the fake Signal Hub, which speaks the real wire protocol. Client feedback: September 28, Joe said crashing an engineer's Python session is not acceptable, and the bridge recovery answers that. October feedback is in the MoMs.</a:t>
+              <a:t>Genevieve Kochel presents this slide, about 45 seconds.</a:t>
+            </a:r>
+          </a:p>
+          <a:p>
+            <a:r>
+              <a:t>The integration and system tests run the SDK against the fake Signal Hub, which speaks the same wire protocol as SEL's hub. On September 28 Joe said crashing an engineer's Python session is not acceptable, and the bridge recovery is the answer to that. October feedback is in the MoMs.</a:t>
             </a:r>
           </a:p>
         </p:txBody>
@@ -1313,12 +1313,12 @@
           <a:lstStyle/>
           <a:p>
             <a:r>
-              <a:t>Presenter: Darron Li. About 45 seconds.</a:t>
-            </a:r>
-          </a:p>
-          <a:p>
-            <a:r>
-              <a:t>Show the board. Done has #44, #45 and #52 to #54, In review has #46, #48 to #50 and PR #51, Ready has #36 and #55. Each member names their issues.</a:t>
+              <a:t>Darron Li presents this slide, about 45 seconds.</a:t>
+            </a:r>
+          </a:p>
+          <a:p>
+            <a:r>
+              <a:t>Show the board. Done has #44 to #46, #48 to #50 and #52 to #54. Ready has #36 and #55. Each member names their issues.</a:t>
             </a:r>
           </a:p>
         </p:txBody>
@@ -1388,12 +1388,12 @@
           <a:lstStyle/>
           <a:p>
             <a:r>
-              <a:t>Presenter: Darron Li. About 45 seconds.</a:t>
-            </a:r>
-          </a:p>
-          <a:p>
-            <a:r>
-              <a:t>Open Sprints/Sprint_5/MoM on GitHub. The files follow the Sprint 4 format. October 12 was the Go and C# comparison. October 26 was the Sprint 5 review.</a:t>
+              <a:t>Darron Li presents this slide, about 45 seconds.</a:t>
+            </a:r>
+          </a:p>
+          <a:p>
+            <a:r>
+              <a:t>Open Sprints/Sprint_5/MoM on GitHub. The files follow the Sprint 4 format. October 12 was the Go and C# comparison, and October 26 was the Sprint 5 review.</a:t>
             </a:r>
           </a:p>
         </p:txBody>
@@ -1463,12 +1463,12 @@
           <a:lstStyle/>
           <a:p>
             <a:r>
-              <a:t>Presenter: Lucas Phillips. About 1 minute 15 seconds.</a:t>
-            </a:r>
-          </a:p>
-          <a:p>
-            <a:r>
-              <a:t>Scroll through Sprints/Sprint_5/Sprint_Report.md on the PR branch. Point out the deliverable status table, issue lists and retrospective. Then the new section V in the final report, the docs/Sprint5 folder and the README.</a:t>
+              <a:t>Lucas Phillips presents this slide, about 1 minute 15 seconds.</a:t>
+            </a:r>
+          </a:p>
+          <a:p>
+            <a:r>
+              <a:t>Scroll through Sprints/Sprint_5/Sprint_Report.md on GitHub and point out the issue lists and the retrospective. Then show the new section V in the final report, the docs/Sprint5 folder and the README.</a:t>
             </a:r>
           </a:p>
         </p:txBody>
@@ -1538,12 +1538,12 @@
           <a:lstStyle/>
           <a:p>
             <a:r>
-              <a:t>Presenter: Caleb Hansen. About 1 minute 30 seconds.</a:t>
-            </a:r>
-          </a:p>
-          <a:p>
-            <a:r>
-              <a:t>Disclose that Claude was used for the spike code, CI workflow, doc drafts, report and slides, and to pull numbers from logs. Give the real example of an AI mistake caught by running the code. Say that every number comes from a log or CI run, SEL code never went to a public tool, and the team owns every deliverable.</a:t>
+              <a:t>Caleb Hansen presents this slide, about 1 minute 30 seconds.</a:t>
+            </a:r>
+          </a:p>
+          <a:p>
+            <a:r>
+              <a:t>Say that Claude was used for the Python.NET test code, doc drafts, the report and the slides, and to pull numbers out of logs. Give the example of an AI mistake that running the code caught. Every number comes from a log or a CI run, SEL code never went to a public tool, and the team owns every deliverable.</a:t>
             </a:r>
           </a:p>
         </p:txBody>
@@ -1613,12 +1613,12 @@
           <a:lstStyle/>
           <a:p>
             <a:r>
-              <a:t>Presenter: Genevieve Kochel. About 45 seconds.</a:t>
-            </a:r>
-          </a:p>
-          <a:p>
-            <a:r>
-              <a:t>Achievements, then each challenge with what was done about it. Close with how Sprint 5 built on Sprint 4.</a:t>
+              <a:t>Genevieve Kochel presents this slide, about 45 seconds.</a:t>
+            </a:r>
+          </a:p>
+          <a:p>
+            <a:r>
+              <a:t>Go through the achievements, then each challenge and what was done about it. Close with how Sprint 5 built on Sprint 4.</a:t>
             </a:r>
           </a:p>
         </p:txBody>
@@ -1688,12 +1688,12 @@
           <a:lstStyle/>
           <a:p>
             <a:r>
-              <a:t>Presenter: Darron Li. About 45 seconds.</a:t>
-            </a:r>
-          </a:p>
-          <a:p>
-            <a:r>
-              <a:t>Sprint 6 plan first, then what went well and what to change. End with what was done because of Joe's feedback.</a:t>
+              <a:t>Darron Li presents this slide, about 45 seconds.</a:t>
+            </a:r>
+          </a:p>
+          <a:p>
+            <a:r>
+              <a:t>Start with the Sprint 6 plan, then what went well and what to change. End with what was done because of Joe's feedback.</a:t>
             </a:r>
           </a:p>
         </p:txBody>
@@ -1763,12 +1763,12 @@
           <a:lstStyle/>
           <a:p>
             <a:r>
-              <a:t>Presenter: Lucas Phillips. About 30 seconds.</a:t>
-            </a:r>
-          </a:p>
-          <a:p>
-            <a:r>
-              <a:t>Recap: working SDK on the bridge with crash recovery, real CI, measured C# results, first docs. Sprint 6 is the C# client and deployment. Thank Joe, SEL and the course staff, and invite questions.</a:t>
+              <a:t>Lucas Phillips presents this slide, about 30 seconds.</a:t>
+            </a:r>
+          </a:p>
+          <a:p>
+            <a:r>
+              <a:t>Recap the working SDK on the bridge with crash recovery, the team CI pipeline, the measured C# results and the first docs. Sprint 6 is the C# client and deployment. Thank Joe, SEL and the course staff, and invite questions.</a:t>
             </a:r>
           </a:p>
         </p:txBody>
@@ -1838,12 +1838,12 @@
           <a:lstStyle/>
           <a:p>
             <a:r>
-              <a:t>Presenter: Lucas Phillips. About 45 seconds.</a:t>
-            </a:r>
-          </a:p>
-          <a:p>
-            <a:r>
-              <a:t>One line on the project, then each person and their Sprint 5 role from the project plan. Finish with the Sprint 5 goal. Do not claim work in this slide, the feature slides cover that.</a:t>
+              <a:t>Lucas Phillips presents this slide, about 45 seconds.</a:t>
+            </a:r>
+          </a:p>
+          <a:p>
+            <a:r>
+              <a:t>Give the project in one line, then introduce each person and their Sprint 5 role. End with the Sprint 5 goal.</a:t>
             </a:r>
           </a:p>
         </p:txBody>
@@ -1913,12 +1913,12 @@
           <a:lstStyle/>
           <a:p>
             <a:r>
-              <a:t>Presenter: Caleb Hansen. About 45 seconds.</a:t>
-            </a:r>
-          </a:p>
-          <a:p>
-            <a:r>
-              <a:t>Go through the four deliverables from the Sprint 4 to 6 plan. The rationale is Joe's rule of no double maintenance, so the bindings wrap a client instead of porting it. The long term goal is engineers scripting Signal Hub from Python with numpy.</a:t>
+              <a:t>Caleb Hansen presents this slide, about 45 seconds.</a:t>
+            </a:r>
+          </a:p>
+          <a:p>
+            <a:r>
+              <a:t>Go through the four deliverables from the Sprint 4 to 6 plan. The reason behind them is Joe's rule against double maintenance, so the SDK wraps a client instead of porting it. Long term, engineers should be able to script Signal Hub from Python with numpy.</a:t>
             </a:r>
           </a:p>
         </p:txBody>
@@ -1988,12 +1988,12 @@
           <a:lstStyle/>
           <a:p>
             <a:r>
-              <a:t>Presenter: Lucas Phillips. About 30 seconds.</a:t>
-            </a:r>
-          </a:p>
-          <a:p>
-            <a:r>
-              <a:t>Each member names their features and issues. Caleb shows the team CI run (#52), Genevieve the C# evaluation status and the user guide (#36, #53), Darron the compatibility roadmap (#54). Lucas demos the bridge, the pub/sub example, and the Python.NET spike on the next slides.</a:t>
+              <a:t>Lucas Phillips presents this slide, about 30 seconds.</a:t>
+            </a:r>
+          </a:p>
+          <a:p>
+            <a:r>
+              <a:t>Each member names their own issues. Caleb shows the team CI run (#52). Genevieve covers the C# evaluation status and the user guide review (#36, #53). Darron covers the compatibility roadmap (#54). Lucas demos the bridge, the pub/sub example and the Python.NET results on the next slides.</a:t>
             </a:r>
           </a:p>
         </p:txBody>
@@ -2063,12 +2063,12 @@
           <a:lstStyle/>
           <a:p>
             <a:r>
-              <a:t>Presenter: Lucas Phillips. About 1 minute.</a:t>
-            </a:r>
-          </a:p>
-          <a:p>
-            <a:r>
-              <a:t>Initial state: in Sprint 4 a dead bridge raised an error and every object was lost. Now with auto_restart=True the SDK starts a new bridge and resumes. Validation: 17 hardening tests and 13 name and cancel tests, all passing in the October 30 run.</a:t>
+              <a:t>Lucas Phillips presents this slide, about 1 minute.</a:t>
+            </a:r>
+          </a:p>
+          <a:p>
+            <a:r>
+              <a:t>In Sprint 4 a dead bridge raised an error and every open object was lost. Now, with auto_restart=True, the SDK starts a new bridge and picks up where it left off. This is backed by 17 hardening tests and 13 name and cancel tests, and all of them passed in the October 30 run.</a:t>
             </a:r>
           </a:p>
         </p:txBody>
@@ -2138,12 +2138,12 @@
           <a:lstStyle/>
           <a:p>
             <a:r>
-              <a:t>Presenter: Lucas Phillips. About 45 seconds.</a:t>
-            </a:r>
-          </a:p>
-          <a:p>
-            <a:r>
-              <a:t>Live demo: start build/testhub, then run docs/Sprint5/examples/pubsub_example.py with the hub port. Then open the demo app (PYTHONPATH=python python3 demo/server.py, http://127.0.0.1:8765), add a publisher and a subscriber, send a batch, and press Kill bridge to show recovery. If not live, show the captured output.</a:t>
+              <a:t>Lucas Phillips presents this slide, about 45 seconds.</a:t>
+            </a:r>
+          </a:p>
+          <a:p>
+            <a:r>
+              <a:t>For the live demo, start build/testhub, then run docs/Sprint5/examples/pubsub_example.py with the hub port. Then open the demo app with PYTHONPATH=python python3 demo/server.py at http://127.0.0.1:8765. Add a publisher and a subscriber, send a batch, and press Kill bridge to show the recovery. If it is not live, show the captured output.</a:t>
             </a:r>
           </a:p>
         </p:txBody>
@@ -2213,12 +2213,12 @@
           <a:lstStyle/>
           <a:p>
             <a:r>
-              <a:t>Presenter: Genevieve Kochel. About 1 minute 15 seconds.</a:t>
-            </a:r>
-          </a:p>
-          <a:p>
-            <a:r>
-              <a:t>Context: the C# client was not on our machines, so Lucas measured Python.NET with a stand-in C# class (no SEL code). Point out that generics and callbacks were most of the Go glue work. Then the catch: a fatal .NET error kills Python, the same as ctypes. That is why the Go bridge stays as the fallback. Numbers are from local runs on October 30.</a:t>
+              <a:t>Genevieve Kochel presents this slide, about 1 minute 15 seconds.</a:t>
+            </a:r>
+          </a:p>
+          <a:p>
+            <a:r>
+              <a:t>The C# client was not on our machines, so Lucas measured Python.NET with a stand-in C# class that has no SEL code in it. Generics and callbacks were most of the Go glue work, and here they need no glue at all. The catch is that a fatal .NET error still kills Python, the same as ctypes, which is why the Go bridge stays as the fallback. The numbers are from local runs on October 30.</a:t>
             </a:r>
           </a:p>
         </p:txBody>
@@ -2288,12 +2288,12 @@
           <a:lstStyle/>
           <a:p>
             <a:r>
-              <a:t>Presenter: Caleb Hansen. About 1 minute 15 seconds.</a:t>
-            </a:r>
-          </a:p>
-          <a:p>
-            <a:r>
-              <a:t>Blueframe runs signed, containerized apps on SEL-3350, 3355 and 3360 computers. Walk the four steps. Be clear about status: steps 1 and 2 are done on developer machines and in CI. Steps 3 and 4 need SEL's signing process and a device or virtual Blueframe instance, which the team does not have yet. That is the first Sprint 6 request to Joe.</a:t>
+              <a:t>Caleb Hansen presents this slide, about 1 minute 15 seconds.</a:t>
+            </a:r>
+          </a:p>
+          <a:p>
+            <a:r>
+              <a:t>Blueframe runs signed, containerized apps on SEL-3350, 3355 and 3360 computers. Walk through the four steps. Steps 1 and 2 are done on developer machines and in CI. Steps 3 and 4 need SEL's signing process and a device or a virtual Blueframe instance, which the team does not have yet. That is the first Sprint 6 request to Joe.</a:t>
             </a:r>
           </a:p>
         </p:txBody>
@@ -2363,12 +2363,12 @@
           <a:lstStyle/>
           <a:p>
             <a:r>
-              <a:t>Presenter: Caleb Hansen. About 45 seconds.</a:t>
-            </a:r>
-          </a:p>
-          <a:p>
-            <a:r>
-              <a:t>Show the team CI pipeline run on the Sprint 5 branch (run 41146542375), 13 of 13 jobs passed. It runs on every push and pull request. Then the compatibility matrix in docs/Sprint5.</a:t>
+              <a:t>Caleb Hansen presents this slide, about 45 seconds.</a:t>
+            </a:r>
+          </a:p>
+          <a:p>
+            <a:r>
+              <a:t>Show the team CI pipeline run on the Sprint 5 branch, run 41146542375, where 13 of 13 jobs passed. It runs on every push and pull request. Then show the compatibility matrix in docs/Sprint5.</a:t>
             </a:r>
           </a:p>
         </p:txBody>
@@ -23432,7 +23432,7 @@
                   <a:srgbClr val="003A5D"/>
                 </a:solidFill>
               </a:rPr>
-              <a:t>Pub/sub example run end to end</a:t>
+              <a:t>The pub/sub example run end to end</a:t>
             </a:r>
           </a:p>
         </p:txBody>
@@ -23503,7 +23503,7 @@
                   <a:srgbClr val="003A5D"/>
                 </a:solidFill>
               </a:rPr>
-              <a:t>Bridge killed mid stream, resumed with no loss</a:t>
+              <a:t>The bridge was killed mid stream and resumed with no loss</a:t>
             </a:r>
           </a:p>
           <a:p>
@@ -23518,7 +23518,7 @@
                   <a:srgbClr val="003A5D"/>
                 </a:solidFill>
               </a:rPr>
-              <a:t>Fork, Ctrl+C, timeouts and duplicate names tested</a:t>
+              <a:t>Fork, Ctrl+C, timeouts and duplicate names were tested</a:t>
             </a:r>
           </a:p>
           <a:p>
@@ -23533,7 +23533,7 @@
                   <a:srgbClr val="003A5D"/>
                 </a:solidFill>
               </a:rPr>
-              <a:t>Python.NET call cost and callback rate measured</a:t>
+              <a:t>Python.NET call cost and callback rate were measured</a:t>
             </a:r>
           </a:p>
         </p:txBody>
@@ -23604,7 +23604,7 @@
                   <a:srgbClr val="003A5D"/>
                 </a:solidFill>
               </a:rPr>
-              <a:t>Sept 28: crashing a Python session is not acceptable. Sprint 5 bridge recovery answers it.</a:t>
+              <a:t>On September 28 Joe said a crashed Python session is not acceptable, and Sprint 5 bridge recovery answers it.</a:t>
             </a:r>
           </a:p>
           <a:p>
@@ -23634,7 +23634,7 @@
                   <a:srgbClr val="003A5D"/>
                 </a:solidFill>
               </a:rPr>
-              <a:t>Not tested on a real Signal Hub yet.</a:t>
+              <a:t>Not tested on SEL's own Signal Hub yet.</a:t>
             </a:r>
           </a:p>
         </p:txBody>
@@ -23773,7 +23773,7 @@
                   <a:srgbClr val="003A5D"/>
                 </a:solidFill>
               </a:rPr>
-              <a:t>Lucas: #44 to #46, #48 to #50</a:t>
+              <a:t>Lucas has #44 to #46 and #48 to #50</a:t>
             </a:r>
           </a:p>
           <a:p>
@@ -23788,7 +23788,7 @@
                   <a:srgbClr val="003A5D"/>
                 </a:solidFill>
               </a:rPr>
-              <a:t>Caleb: #52, #55</a:t>
+              <a:t>Caleb has #52</a:t>
             </a:r>
           </a:p>
           <a:p>
@@ -23803,7 +23803,7 @@
                   <a:srgbClr val="003A5D"/>
                 </a:solidFill>
               </a:rPr>
-              <a:t>Genevieve: #36, #53, #55</a:t>
+              <a:t>Genevieve has #36 and #53</a:t>
             </a:r>
           </a:p>
           <a:p>
@@ -23818,7 +23818,7 @@
                   <a:srgbClr val="003A5D"/>
                 </a:solidFill>
               </a:rPr>
-              <a:t>Darron: #54, #55</a:t>
+              <a:t>Darron has #54</a:t>
             </a:r>
           </a:p>
           <a:p>
@@ -23833,7 +23833,22 @@
                   <a:srgbClr val="003A5D"/>
                 </a:solidFill>
               </a:rPr>
-              <a:t>Every issue has an owner, milestone, priority and story point label.</a:t>
+              <a:t>Everyone shares #55, the video</a:t>
+            </a:r>
+          </a:p>
+          <a:p>
+            <a:pPr>
+              <a:spcAft>
+                <a:spcPts val="500"/>
+              </a:spcAft>
+            </a:pPr>
+            <a:r>
+              <a:rPr sz="1300">
+                <a:solidFill>
+                  <a:srgbClr val="003A5D"/>
+                </a:solidFill>
+              </a:rPr>
+              <a:t>Every issue has an owner, a milestone, a priority and a story point label.</a:t>
             </a:r>
           </a:p>
         </p:txBody>
@@ -23972,7 +23987,7 @@
                   <a:srgbClr val="003A5D"/>
                 </a:solidFill>
               </a:rPr>
-              <a:t>What Go makes hard: generics, callbacks, process ownership</a:t>
+              <a:t>What Go makes hard, which is generics, callbacks and process ownership</a:t>
             </a:r>
           </a:p>
           <a:p>
@@ -24002,7 +24017,7 @@
                   <a:srgbClr val="003A5D"/>
                 </a:solidFill>
               </a:rPr>
-              <a:t>Open decisions and a real Signal Hub request</a:t>
+              <a:t>Open decisions and a request for SEL's Signal Hub</a:t>
             </a:r>
           </a:p>
         </p:txBody>
@@ -24073,7 +24088,7 @@
                   <a:srgbClr val="003A5D"/>
                 </a:solidFill>
               </a:rPr>
-              <a:t>C# client still not available (#36)</a:t>
+              <a:t>The C# client is still not available (#36)</a:t>
             </a:r>
           </a:p>
           <a:p>
@@ -24088,7 +24103,7 @@
                   <a:srgbClr val="003A5D"/>
                 </a:solidFill>
               </a:rPr>
-              <a:t>Bindings, tests and CI status</a:t>
+              <a:t>Status of the bindings, tests and CI</a:t>
             </a:r>
           </a:p>
           <a:p>
@@ -24103,7 +24118,7 @@
                   <a:srgbClr val="003A5D"/>
                 </a:solidFill>
               </a:rPr>
-              <a:t>Deployment needs and Sprint 6 plan</a:t>
+              <a:t>Deployment needs and the Sprint 6 plan</a:t>
             </a:r>
           </a:p>
         </p:txBody>
@@ -24313,7 +24328,7 @@
                   <a:srgbClr val="003A5D"/>
                 </a:solidFill>
               </a:rPr>
-              <a:t>User guide, compatibility matrix, deployment plan</a:t>
+              <a:t>User guide, compatibility matrix and deployment plan</a:t>
             </a:r>
           </a:p>
         </p:txBody>
@@ -24369,7 +24384,7 @@
                   <a:srgbClr val="003A5D"/>
                 </a:solidFill>
               </a:rPr>
-              <a:t>code/pythonnet-spike</a:t>
+              <a:t>Python.NET tests</a:t>
             </a:r>
           </a:p>
           <a:p>
@@ -24384,7 +24399,7 @@
                   <a:srgbClr val="003A5D"/>
                 </a:solidFill>
               </a:rPr>
-              <a:t>Spike, tests, results</a:t>
+              <a:t>Stand-in C# class, tests and results in code/</a:t>
             </a:r>
           </a:p>
         </p:txBody>
@@ -24455,7 +24470,7 @@
                   <a:srgbClr val="003A5D"/>
                 </a:solidFill>
               </a:rPr>
-              <a:t>New section V, test specifications and results</a:t>
+              <a:t>New section V with test specifications and results</a:t>
             </a:r>
           </a:p>
         </p:txBody>
@@ -24636,7 +24651,7 @@
                   <a:srgbClr val="003A5D"/>
                 </a:solidFill>
               </a:rPr>
-              <a:t>Tool: Claude, through Claude Code</a:t>
+              <a:t>Claude, through Claude Code, was the tool used</a:t>
             </a:r>
           </a:p>
           <a:p>
@@ -24651,7 +24666,7 @@
                   <a:srgbClr val="003A5D"/>
                 </a:solidFill>
               </a:rPr>
-              <a:t>Python.NET spike and its tests</a:t>
+              <a:t>Python.NET test code and its tests</a:t>
             </a:r>
           </a:p>
           <a:p>
@@ -24767,7 +24782,7 @@
                   <a:srgbClr val="003A5D"/>
                 </a:solidFill>
               </a:rPr>
-              <a:t>The first spike run failed because a folder name hid the .NET namespace. Running it caught that.</a:t>
+              <a:t>The first Python.NET run failed because a folder name hid the .NET namespace. Running it caught that.</a:t>
             </a:r>
           </a:p>
           <a:p>
@@ -24782,7 +24797,7 @@
                   <a:srgbClr val="003A5D"/>
                 </a:solidFill>
               </a:rPr>
-              <a:t>Every number in the report comes from a test log or CI run.</a:t>
+              <a:t>Every number in the report comes from a test log or a CI run.</a:t>
             </a:r>
           </a:p>
           <a:p>
@@ -24937,7 +24952,7 @@
                   <a:srgbClr val="003A5D"/>
                 </a:solidFill>
               </a:rPr>
-              <a:t>Bridge recovers from crashes, with tests</a:t>
+              <a:t>The bridge recovers from crashes, with tests to show it</a:t>
             </a:r>
           </a:p>
           <a:p>
@@ -24967,7 +24982,7 @@
                   <a:srgbClr val="003A5D"/>
                 </a:solidFill>
               </a:rPr>
-              <a:t>Team CI pipeline green on the Sprint 5 branch</a:t>
+              <a:t>The team CI pipeline is green on the Sprint 5 branch</a:t>
             </a:r>
           </a:p>
           <a:p>
@@ -24982,7 +24997,7 @@
                   <a:srgbClr val="003A5D"/>
                 </a:solidFill>
               </a:rPr>
-              <a:t>First user guide and pub/sub example</a:t>
+              <a:t>There is a first user guide and pub/sub example</a:t>
             </a:r>
           </a:p>
         </p:txBody>
@@ -25053,7 +25068,7 @@
                   <a:srgbClr val="003A5D"/>
                 </a:solidFill>
               </a:rPr>
-              <a:t>No C# client. Kept the bridge and ran a stand-in spike.</a:t>
+              <a:t>There was no C# client, so the bridge was kept and Python.NET was tested with a stand-in class.</a:t>
             </a:r>
           </a:p>
           <a:p>
@@ -25068,7 +25083,7 @@
                   <a:srgbClr val="003A5D"/>
                 </a:solidFill>
               </a:rPr>
-              <a:t>No real Signal Hub. All tests use the fake hub.</a:t>
+              <a:t>There is no SEL Signal Hub to test on, so all tests use the fake hub.</a:t>
             </a:r>
           </a:p>
           <a:p>
@@ -25083,7 +25098,7 @@
                   <a:srgbClr val="003A5D"/>
                 </a:solidFill>
               </a:rPr>
-              <a:t>SEL code is private. Results are shared, code is not.</a:t>
+              <a:t>SEL code is private, so results are shared and code is not.</a:t>
             </a:r>
           </a:p>
         </p:txBody>
@@ -25339,7 +25354,7 @@
                   <a:srgbClr val="003A5D"/>
                 </a:solidFill>
               </a:rPr>
-              <a:t>Prototype suite in private CI</a:t>
+              <a:t>Put the prototype suite in private CI</a:t>
             </a:r>
           </a:p>
           <a:p>
@@ -25425,7 +25440,7 @@
                   <a:srgbClr val="003A5D"/>
                 </a:solidFill>
               </a:rPr>
-              <a:t>Went well: the fallback plan, tests before fixes</a:t>
+              <a:t>The fallback plan and writing tests before fixes went well</a:t>
             </a:r>
           </a:p>
           <a:p>
@@ -25440,7 +25455,7 @@
                   <a:srgbClr val="003A5D"/>
                 </a:solidFill>
               </a:rPr>
-              <a:t>Improve: ask for the client in writing with a date</a:t>
+              <a:t>Next time the client should be requested in writing with a date</a:t>
             </a:r>
           </a:p>
           <a:p>
@@ -25455,7 +25470,7 @@
                   <a:srgbClr val="003A5D"/>
                 </a:solidFill>
               </a:rPr>
-              <a:t>Improve: every member's work on the board, code pushed weekly</a:t>
+              <a:t>Every member's work should be on the board and code pushed weekly</a:t>
             </a:r>
           </a:p>
         </p:txBody>
@@ -25526,7 +25541,7 @@
                   <a:srgbClr val="003A5D"/>
                 </a:solidFill>
               </a:rPr>
-              <a:t>No double maintenance: still wrapping, not porting</a:t>
+              <a:t>The SDK still wraps the client and does not port it</a:t>
             </a:r>
           </a:p>
           <a:p>
@@ -25541,7 +25556,7 @@
                   <a:srgbClr val="003A5D"/>
                 </a:solidFill>
               </a:rPr>
-              <a:t>No crashed Python sessions: bridge recovery</a:t>
+              <a:t>Bridge recovery keeps Python sessions alive</a:t>
             </a:r>
           </a:p>
           <a:p>
@@ -25556,7 +25571,7 @@
                   <a:srgbClr val="003A5D"/>
                 </a:solidFill>
               </a:rPr>
-              <a:t>C# move: spike done, client next</a:t>
+              <a:t>Python.NET is measured and the C# client is next</a:t>
             </a:r>
           </a:p>
           <a:p>
@@ -25571,7 +25586,7 @@
                   <a:srgbClr val="003A5D"/>
                 </a:solidFill>
               </a:rPr>
-              <a:t>Docs as a deliverable: user guide</a:t>
+              <a:t>Docs are a deliverable, so there is a user guide</a:t>
             </a:r>
           </a:p>
         </p:txBody>
@@ -25759,7 +25774,7 @@
                   <a:srgbClr val="003A5D"/>
                 </a:solidFill>
               </a:rPr>
-              <a:t>Blueframe apps move grid data through Signal Hub. SEL has Go and C# clients, but most engineers write Python.</a:t>
+              <a:t>Blueframe apps send grid data through Signal Hub. SEL has Go and C# clients, but most engineers write Python.</a:t>
             </a:r>
           </a:p>
           <a:p>
@@ -25774,7 +25789,7 @@
                   <a:srgbClr val="003A5D"/>
                 </a:solidFill>
               </a:rPr>
-              <a:t>The SDK wraps an existing client so SEL never maintains a third copy.</a:t>
+              <a:t>The SDK wraps an existing client, so SEL never has to maintain a third copy.</a:t>
             </a:r>
           </a:p>
         </p:txBody>
@@ -25845,7 +25860,7 @@
                   <a:srgbClr val="003A5D"/>
                 </a:solidFill>
               </a:rPr>
-              <a:t>Python bindings that a script can import for publish and subscribe, automated tests, compatibility results, and first user docs.</a:t>
+              <a:t>Python bindings that a script can import to publish and subscribe, with automated tests, compatibility results and user docs.</a:t>
             </a:r>
           </a:p>
         </p:txBody>
@@ -25896,7 +25911,7 @@
               </a:spcAft>
             </a:pPr>
             <a:r>
-              <a:rPr sz="1800" b="1">
+              <a:rPr sz="1600" b="1">
                 <a:solidFill>
                   <a:srgbClr val="003A5D"/>
                 </a:solidFill>
@@ -25911,12 +25926,12 @@
               </a:spcAft>
             </a:pPr>
             <a:r>
-              <a:rPr sz="1600">
+              <a:rPr sz="1400">
                 <a:solidFill>
                   <a:srgbClr val="003A5D"/>
                 </a:solidFill>
               </a:rPr>
-              <a:t>Bindings on the bridge, Python.NET spike, docs</a:t>
+              <a:t>Bindings on the bridge, Python.NET tests, docs</a:t>
             </a:r>
           </a:p>
         </p:txBody>
@@ -25967,7 +25982,7 @@
               </a:spcAft>
             </a:pPr>
             <a:r>
-              <a:rPr sz="1800" b="1">
+              <a:rPr sz="1600" b="1">
                 <a:solidFill>
                   <a:srgbClr val="003A5D"/>
                 </a:solidFill>
@@ -25982,7 +25997,7 @@
               </a:spcAft>
             </a:pPr>
             <a:r>
-              <a:rPr sz="1600">
+              <a:rPr sz="1400">
                 <a:solidFill>
                   <a:srgbClr val="003A5D"/>
                 </a:solidFill>
@@ -26038,7 +26053,7 @@
               </a:spcAft>
             </a:pPr>
             <a:r>
-              <a:rPr sz="1800" b="1">
+              <a:rPr sz="1600" b="1">
                 <a:solidFill>
                   <a:srgbClr val="003A5D"/>
                 </a:solidFill>
@@ -26053,12 +26068,12 @@
               </a:spcAft>
             </a:pPr>
             <a:r>
-              <a:rPr sz="1600">
+              <a:rPr sz="1400">
                 <a:solidFill>
                   <a:srgbClr val="003A5D"/>
                 </a:solidFill>
               </a:rPr>
-              <a:t>C# client evaluation (#36), user docs owner</a:t>
+              <a:t>C# client evaluation and user docs owner</a:t>
             </a:r>
           </a:p>
         </p:txBody>
@@ -26109,7 +26124,7 @@
               </a:spcAft>
             </a:pPr>
             <a:r>
-              <a:rPr sz="1800" b="1">
+              <a:rPr sz="1600" b="1">
                 <a:solidFill>
                   <a:srgbClr val="003A5D"/>
                 </a:solidFill>
@@ -26124,7 +26139,7 @@
               </a:spcAft>
             </a:pPr>
             <a:r>
-              <a:rPr sz="1600">
+              <a:rPr sz="1400">
                 <a:solidFill>
                   <a:srgbClr val="003A5D"/>
                 </a:solidFill>
@@ -26381,7 +26396,7 @@
                   <a:srgbClr val="003A5D"/>
                 </a:solidFill>
               </a:rPr>
-              <a:t>Agreed Python version and operating systems, with test logs.</a:t>
+              <a:t>The agreed Python version and operating systems, with test logs.</a:t>
             </a:r>
           </a:p>
         </p:txBody>
@@ -26624,7 +26639,7 @@
                   <a:srgbClr val="003A5D"/>
                 </a:solidFill>
               </a:rPr>
-              <a:t>SEL keeps one client. The Python layer only translates.</a:t>
+              <a:t>SEL keeps one client, and the Python layer only translates.</a:t>
             </a:r>
           </a:p>
         </p:txBody>
@@ -26915,7 +26930,7 @@
                     <a:p>
                       <a:r>
                         <a:rPr sz="1500"/>
-                        <a:t>Python.NET spike</a:t>
+                        <a:t>Python.NET evaluation with a stand-in C# class</a:t>
                       </a:r>
                     </a:p>
                   </a:txBody>
@@ -26941,7 +26956,7 @@
                     <a:p>
                       <a:r>
                         <a:rPr sz="1500"/>
-                        <a:t>In review</a:t>
+                        <a:t>Done</a:t>
                       </a:r>
                     </a:p>
                   </a:txBody>
@@ -27008,7 +27023,7 @@
                     <a:p>
                       <a:r>
                         <a:rPr sz="1500"/>
-                        <a:t>In review</a:t>
+                        <a:t>Done</a:t>
                       </a:r>
                     </a:p>
                   </a:txBody>
@@ -27075,7 +27090,7 @@
                     <a:p>
                       <a:r>
                         <a:rPr sz="1500"/>
-                        <a:t>In review</a:t>
+                        <a:t>Done</a:t>
                       </a:r>
                     </a:p>
                   </a:txBody>
@@ -27400,7 +27415,7 @@
                   <a:srgbClr val="555F6B"/>
                 </a:solidFill>
               </a:rPr>
-              <a:t>Bridge and demo code is in the private gosignals repo because the client is SEL Confidential.</a:t>
+              <a:t>The bridge and demo code is in the private gosignals repo because the client is SEL Confidential.</a:t>
             </a:r>
           </a:p>
         </p:txBody>
@@ -27439,7 +27454,7 @@
           <a:lstStyle/>
           <a:p>
             <a:r>
-              <a:t>Feature: Bridge Crash Recovery</a:t>
+              <a:t>Bridge Crash Recovery</a:t>
             </a:r>
           </a:p>
         </p:txBody>
@@ -27510,7 +27525,7 @@
                   <a:srgbClr val="003A5D"/>
                 </a:solidFill>
               </a:rPr>
-              <a:t>Before: a Go crash in the bridge ended every subscription.</a:t>
+              <a:t>In Sprint 4, a Go crash in the bridge ended every subscription.</a:t>
             </a:r>
           </a:p>
           <a:p>
@@ -27525,7 +27540,7 @@
                   <a:srgbClr val="003A5D"/>
                 </a:solidFill>
               </a:rPr>
-              <a:t>Now: auto_restart starts a new bridge, and subscriptions resume from the last timestamp with no gaps or duplicates.</a:t>
+              <a:t>Now auto_restart starts a new bridge, and subscriptions resume from the last timestamp with no gaps or duplicates.</a:t>
             </a:r>
           </a:p>
           <a:p>
@@ -27540,7 +27555,7 @@
                   <a:srgbClr val="003A5D"/>
                 </a:solidFill>
               </a:rPr>
-              <a:t>A duplicate client name fails at once with a clear error. unique_name=True avoids it.</a:t>
+              <a:t>A duplicate client name fails at once with a clear error, and unique_name=True avoids it.</a:t>
             </a:r>
           </a:p>
           <a:p>
@@ -27942,7 +27957,7 @@
           <a:lstStyle/>
           <a:p>
             <a:r>
-              <a:t>Demo: Publish and Subscribe from Python</a:t>
+              <a:t>Publish and Subscribe Demo</a:t>
             </a:r>
           </a:p>
         </p:txBody>
@@ -28128,7 +28143,7 @@
                   <a:srgbClr val="003A5D"/>
                 </a:solidFill>
               </a:rPr>
-              <a:t>Publishers, the hub, and subscribers on one local page.</a:t>
+              <a:t>Publishers, the hub and subscribers are on one local page.</a:t>
             </a:r>
           </a:p>
           <a:p>
@@ -28212,7 +28227,7 @@
           <a:lstStyle/>
           <a:p>
             <a:r>
-              <a:t>Feature: Python.NET Spike</a:t>
+              <a:t>Python.NET Evaluation</a:t>
             </a:r>
           </a:p>
         </p:txBody>
@@ -28483,7 +28498,7 @@
                   <a:srgbClr val="003A5D"/>
                 </a:solidFill>
               </a:rPr>
-              <a:t>C# exceptions become Python exceptions</a:t>
+              <a:t>C# exceptions turn into Python exceptions</a:t>
             </a:r>
           </a:p>
           <a:p>
@@ -28780,7 +28795,7 @@
                   <a:srgbClr val="003A5D"/>
                 </a:solidFill>
               </a:rPr>
-              <a:t>Bridge build today. pythonnet plus the C# client after the move.</a:t>
+              <a:t>The bridge build today, and pythonnet plus the C# client after the move.</a:t>
             </a:r>
           </a:p>
           <a:p>
@@ -28866,7 +28881,7 @@
                   <a:srgbClr val="003A5D"/>
                 </a:solidFill>
               </a:rPr>
-              <a:t>Script and SDK packaged and signed with the Field SDK tooling.</a:t>
+              <a:t>The script and SDK are packaged and signed with the Field SDK tooling.</a:t>
             </a:r>
           </a:p>
           <a:p>
@@ -29038,7 +29053,7 @@
                   <a:srgbClr val="003A5D"/>
                 </a:solidFill>
               </a:rPr>
-              <a:t>Can a Blueframe app start a child process (needed by the Go bridge)? Is .NET in the app container? Which Python is in the Field SDK image?</a:t>
+              <a:t>Can a Blueframe app start a child process, which the Go bridge needs? Is .NET in the app container? Which Python is in the Field SDK image?</a:t>
             </a:r>
           </a:p>
         </p:txBody>
@@ -29077,7 +29092,7 @@
           <a:lstStyle/>
           <a:p>
             <a:r>
-              <a:t>Deployment: CI/CD and Compatibility</a:t>
+              <a:t>Deployment CI/CD and Compatibility</a:t>
             </a:r>
           </a:p>
         </p:txBody>
@@ -29192,7 +29207,7 @@
                   <a:srgbClr val="003A5D"/>
                 </a:solidFill>
               </a:rPr>
-              <a:t>Python.NET spike: 6 tests pass on Linux and Windows, Python 3.10, 3.12, 3.13.</a:t>
+              <a:t>The Python.NET tests pass on Linux and Windows with Python 3.10, 3.12 and 3.13.</a:t>
             </a:r>
           </a:p>
           <a:p>
@@ -29207,7 +29222,7 @@
                   <a:srgbClr val="003A5D"/>
                 </a:solidFill>
               </a:rPr>
-              <a:t>Team pipeline: Go 1.21, 1.22, 1.23.</a:t>
+              <a:t>The team pipeline covers Go 1.21, 1.22 and 1.23.</a:t>
             </a:r>
           </a:p>
           <a:p>
@@ -29222,7 +29237,7 @@
                   <a:srgbClr val="003A5D"/>
                 </a:solidFill>
               </a:rPr>
-              <a:t>Go bridge: Linux only. Windows not run yet.</a:t>
+              <a:t>The Go bridge has only run on Linux so far.</a:t>
             </a:r>
           </a:p>
         </p:txBody>

</xml_diff>

<commit_message>
Mark all Sprint 5 issues complete, record deployment and owners
</commit_message>
<xml_diff>
--- a/Sprints/Sprint_5/Sprint 5 Presentation.pptx
+++ b/Sprints/Sprint_5/Sprint 5 Presentation.pptx
@@ -1556,52 +1556,14 @@
           </a:bodyPr>
           <a:lstStyle/>
           <a:p>
-            <a:pPr indent="0" lvl="0" marL="0" rtl="0" algn="l">
-              <a:spcBef>
-                <a:spcPts val="0"/>
-              </a:spcBef>
-              <a:spcAft>
-                <a:spcPts val="0"/>
-              </a:spcAft>
-              <a:buNone/>
-            </a:pPr>
             <a:r>
-              <a:rPr lang="en-US" sz="1100">
-                <a:solidFill>
-                  <a:srgbClr val="000000"/>
-                </a:solidFill>
-                <a:latin typeface="Times New Roman"/>
-                <a:ea typeface="Times New Roman"/>
-                <a:cs typeface="Times New Roman"/>
-                <a:sym typeface="Times New Roman"/>
-              </a:rPr>
               <a:t>Darron Li presents this slide, about 45 seconds.</a:t>
             </a:r>
-            <a:endParaRPr/>
           </a:p>
           <a:p>
-            <a:pPr indent="0" lvl="0" marL="0" rtl="0" algn="l">
-              <a:spcBef>
-                <a:spcPts val="0"/>
-              </a:spcBef>
-              <a:spcAft>
-                <a:spcPts val="0"/>
-              </a:spcAft>
-              <a:buNone/>
-            </a:pPr>
             <a:r>
-              <a:rPr lang="en-US" sz="1100">
-                <a:solidFill>
-                  <a:srgbClr val="000000"/>
-                </a:solidFill>
-                <a:latin typeface="Times New Roman"/>
-                <a:ea typeface="Times New Roman"/>
-                <a:cs typeface="Times New Roman"/>
-                <a:sym typeface="Times New Roman"/>
-              </a:rPr>
-              <a:t>Show the board. Done has #44 to #46, #48 to #50 and #52 to #54. Ready has #36 and #55. Each member names their issues.</a:t>
+              <a:t>Show the board filtered to the Sprint 5 milestone. Every Sprint 5 issue is in Done. Lucas has #44 and #45, Caleb has #46, #47 and #52, Genevieve has #36, #49 and #53, and Darron has #48, #50 and #54. Everyone shares #55, the video. Each member names their issues.</a:t>
             </a:r>
-            <a:endParaRPr/>
           </a:p>
         </p:txBody>
       </p:sp>
@@ -3356,52 +3318,14 @@
           </a:bodyPr>
           <a:lstStyle/>
           <a:p>
-            <a:pPr indent="0" lvl="0" marL="0" rtl="0" algn="l">
-              <a:spcBef>
-                <a:spcPts val="0"/>
-              </a:spcBef>
-              <a:spcAft>
-                <a:spcPts val="0"/>
-              </a:spcAft>
-              <a:buNone/>
-            </a:pPr>
             <a:r>
-              <a:rPr lang="en-US" sz="1100">
-                <a:solidFill>
-                  <a:srgbClr val="000000"/>
-                </a:solidFill>
-                <a:latin typeface="Times New Roman"/>
-                <a:ea typeface="Times New Roman"/>
-                <a:cs typeface="Times New Roman"/>
-                <a:sym typeface="Times New Roman"/>
-              </a:rPr>
               <a:t>Lucas Phillips presents this slide, about 30 seconds.</a:t>
             </a:r>
-            <a:endParaRPr/>
           </a:p>
           <a:p>
-            <a:pPr indent="0" lvl="0" marL="0" rtl="0" algn="l">
-              <a:spcBef>
-                <a:spcPts val="0"/>
-              </a:spcBef>
-              <a:spcAft>
-                <a:spcPts val="0"/>
-              </a:spcAft>
-              <a:buNone/>
-            </a:pPr>
             <a:r>
-              <a:rPr lang="en-US" sz="1100">
-                <a:solidFill>
-                  <a:srgbClr val="000000"/>
-                </a:solidFill>
-                <a:latin typeface="Times New Roman"/>
-                <a:ea typeface="Times New Roman"/>
-                <a:cs typeface="Times New Roman"/>
-                <a:sym typeface="Times New Roman"/>
-              </a:rPr>
-              <a:t>Each member names their own issues. Caleb shows the team CI run (#52). Genevieve covers the C# evaluation status and the user guide review (#36, #53). Darron covers the compatibility roadmap (#54). Lucas demos the bridge, the pub/sub example and the Python.NET results on the next slides.</a:t>
+              <a:t>Each member names their own issues. Lucas covers the bridge and the demo app (#44, #45). Caleb covers the Python.NET evaluation, the CI workflow and the CI run (#46, #47, #52). Genevieve covers the C# evaluation, the compatibility matrix and the user guide review (#36, #49, #53). Darron covers the user guide, the report and the compatibility roadmap (#48, #50, #54).</a:t>
             </a:r>
-            <a:endParaRPr/>
           </a:p>
         </p:txBody>
       </p:sp>
@@ -3923,52 +3847,14 @@
           </a:bodyPr>
           <a:lstStyle/>
           <a:p>
-            <a:pPr indent="0" lvl="0" marL="0" rtl="0" algn="l">
-              <a:spcBef>
-                <a:spcPts val="0"/>
-              </a:spcBef>
-              <a:spcAft>
-                <a:spcPts val="0"/>
-              </a:spcAft>
-              <a:buNone/>
-            </a:pPr>
             <a:r>
-              <a:rPr lang="en-US" sz="1100">
-                <a:solidFill>
-                  <a:srgbClr val="000000"/>
-                </a:solidFill>
-                <a:latin typeface="Times New Roman"/>
-                <a:ea typeface="Times New Roman"/>
-                <a:cs typeface="Times New Roman"/>
-                <a:sym typeface="Times New Roman"/>
-              </a:rPr>
               <a:t>Genevieve Kochel presents this slide, about 1 minute 15 seconds.</a:t>
             </a:r>
-            <a:endParaRPr/>
           </a:p>
           <a:p>
-            <a:pPr indent="0" lvl="0" marL="0" rtl="0" algn="l">
-              <a:spcBef>
-                <a:spcPts val="0"/>
-              </a:spcBef>
-              <a:spcAft>
-                <a:spcPts val="0"/>
-              </a:spcAft>
-              <a:buNone/>
-            </a:pPr>
             <a:r>
-              <a:rPr lang="en-US" sz="1100">
-                <a:solidFill>
-                  <a:srgbClr val="000000"/>
-                </a:solidFill>
-                <a:latin typeface="Times New Roman"/>
-                <a:ea typeface="Times New Roman"/>
-                <a:cs typeface="Times New Roman"/>
-                <a:sym typeface="Times New Roman"/>
-              </a:rPr>
-              <a:t>The C# client was not on our machines, so Lucas measured Python.NET with a stand-in C# class that has no SEL code in it. Generics and callbacks were most of the Go glue work, and here they need no glue at all. The catch is that a fatal .NET error still kills Python, the same as ctypes, which is why the Go bridge stays as the fallback. The numbers are from local runs on October 30.</a:t>
+              <a:t>The C# client was not on our machines, so Caleb measured Python.NET with a stand-in C# class that has no SEL code in it. Generics and callbacks were most of the Go glue work, and here they need no glue at all. The catch is that a fatal .NET error still kills Python, the same as ctypes, which is why the Go bridge stays as the fallback. The numbers are from local runs on October 30.</a:t>
             </a:r>
-            <a:endParaRPr/>
           </a:p>
         </p:txBody>
       </p:sp>
@@ -4112,52 +3998,14 @@
           </a:bodyPr>
           <a:lstStyle/>
           <a:p>
-            <a:pPr indent="0" lvl="0" marL="0" rtl="0" algn="l">
-              <a:spcBef>
-                <a:spcPts val="0"/>
-              </a:spcBef>
-              <a:spcAft>
-                <a:spcPts val="0"/>
-              </a:spcAft>
-              <a:buNone/>
-            </a:pPr>
             <a:r>
-              <a:rPr lang="en-US" sz="1100">
-                <a:solidFill>
-                  <a:srgbClr val="000000"/>
-                </a:solidFill>
-                <a:latin typeface="Times New Roman"/>
-                <a:ea typeface="Times New Roman"/>
-                <a:cs typeface="Times New Roman"/>
-                <a:sym typeface="Times New Roman"/>
-              </a:rPr>
               <a:t>Caleb Hansen presents this slide, about 1 minute 15 seconds.</a:t>
             </a:r>
-            <a:endParaRPr/>
           </a:p>
           <a:p>
-            <a:pPr indent="0" lvl="0" marL="0" rtl="0" algn="l">
-              <a:spcBef>
-                <a:spcPts val="0"/>
-              </a:spcBef>
-              <a:spcAft>
-                <a:spcPts val="0"/>
-              </a:spcAft>
-              <a:buNone/>
-            </a:pPr>
             <a:r>
-              <a:rPr lang="en-US" sz="1100">
-                <a:solidFill>
-                  <a:srgbClr val="000000"/>
-                </a:solidFill>
-                <a:latin typeface="Times New Roman"/>
-                <a:ea typeface="Times New Roman"/>
-                <a:cs typeface="Times New Roman"/>
-                <a:sym typeface="Times New Roman"/>
-              </a:rPr>
-              <a:t>Blueframe runs signed, containerized apps on SEL-3350, 3355 and 3360 computers. Walk through the four steps. Steps 1 and 2 are done on developer machines and in CI. Steps 3 and 4 need SEL's signing process and a device or a virtual Blueframe instance, which the team does not have yet. That is the first Sprint 6 request to Joe.</a:t>
+              <a:t>Blueframe runs signed, containerized apps on SEL-3350, 3355 and 3360 computers. Walk through the four steps. The extension sets up the Field SDK devcontainer, and the SDK and SEL's SignalHub client are deployed against a Signal Hub server running locally. On a device the app talks to Signal Hub the same way. Signing the app needs SEL's signing process, which is the first Sprint 6 request to Joe.</a:t>
             </a:r>
-            <a:endParaRPr/>
           </a:p>
         </p:txBody>
       </p:sp>
@@ -35637,7 +35485,7 @@
                 <a:cs typeface="Arial"/>
                 <a:sym typeface="Arial"/>
               </a:rPr>
-              <a:t>Lucas has #44 to #46 </a:t>
+              <a:t>Lucas has #44 and #45</a:t>
             </a:r>
             <a:endParaRPr/>
           </a:p>
@@ -35680,27 +35528,7 @@
                 <a:cs typeface="Arial"/>
                 <a:sym typeface="Arial"/>
               </a:rPr>
-              <a:t>Caleb has #52, </a:t>
-            </a:r>
-            <a:r>
-              <a:rPr lang="en-US" sz="1300">
-                <a:solidFill>
-                  <a:srgbClr val="003A5D"/>
-                </a:solidFill>
-              </a:rPr>
-              <a:t>#</a:t>
-            </a:r>
-            <a:r>
-              <a:rPr b="0" i="0" lang="en-US" sz="1300" u="none" cap="none" strike="noStrike">
-                <a:solidFill>
-                  <a:srgbClr val="003A5D"/>
-                </a:solidFill>
-                <a:latin typeface="Arial"/>
-                <a:ea typeface="Arial"/>
-                <a:cs typeface="Arial"/>
-                <a:sym typeface="Arial"/>
-              </a:rPr>
-              <a:t>48, #47</a:t>
+              <a:t>Caleb has #46, #47 and #52</a:t>
             </a:r>
             <a:endParaRPr/>
           </a:p>
@@ -35743,7 +35571,7 @@
                 <a:cs typeface="Arial"/>
                 <a:sym typeface="Arial"/>
               </a:rPr>
-              <a:t>Genevieve has #36 and #53</a:t>
+              <a:t>Genevieve has #36, #49 and #53</a:t>
             </a:r>
             <a:endParaRPr/>
           </a:p>
@@ -35786,7 +35614,7 @@
                 <a:cs typeface="Arial"/>
                 <a:sym typeface="Arial"/>
               </a:rPr>
-              <a:t>Darron has #54, #50</a:t>
+              <a:t>Darron has #48, #50 and #54</a:t>
             </a:r>
             <a:endParaRPr/>
           </a:p>
@@ -38137,7 +37965,7 @@
                 <a:cs typeface="Arial"/>
                 <a:sym typeface="Arial"/>
               </a:rPr>
-              <a:t>Get the C# client and finish #36</a:t>
+              <a:t>Get SEL's C# client and start the C# port</a:t>
             </a:r>
             <a:endParaRPr/>
           </a:p>
@@ -41104,7 +40932,7 @@
                       </a:pPr>
                       <a:r>
                         <a:rPr lang="en-US" sz="1500"/>
-                        <a:t>Open, client not available</a:t>
+                        <a:t>Done</a:t>
                       </a:r>
                       <a:endParaRPr/>
                     </a:p>
@@ -42948,7 +42776,7 @@
                 <a:cs typeface="Arial"/>
                 <a:sym typeface="Arial"/>
               </a:rPr>
-              <a:t>SEL's C# client itself is still untested (#36).</a:t>
+              <a:t>#36 used the stand-in class, since SEL's C# client was not on the team's machines.</a:t>
             </a:r>
             <a:endParaRPr/>
           </a:p>

</xml_diff>